<commit_message>
Update: replace introductory pandas slides
</commit_message>
<xml_diff>
--- a/files/ccjs418e_fall2026/Intro_to_Pandas.pptx
+++ b/files/ccjs418e_fall2026/Intro_to_Pandas.pptx
@@ -24,27 +24,20 @@
     <p:sldId id="385" r:id="rId18"/>
     <p:sldId id="392" r:id="rId19"/>
     <p:sldId id="417" r:id="rId20"/>
-    <p:sldId id="419" r:id="rId21"/>
-    <p:sldId id="418" r:id="rId22"/>
-    <p:sldId id="420" r:id="rId23"/>
-    <p:sldId id="421" r:id="rId24"/>
-    <p:sldId id="424" r:id="rId25"/>
-    <p:sldId id="425" r:id="rId26"/>
-    <p:sldId id="426" r:id="rId27"/>
-    <p:sldId id="427" r:id="rId28"/>
-    <p:sldId id="428" r:id="rId29"/>
-    <p:sldId id="429" r:id="rId30"/>
-    <p:sldId id="430" r:id="rId31"/>
-    <p:sldId id="431" r:id="rId32"/>
-    <p:sldId id="432" r:id="rId33"/>
-    <p:sldId id="433" r:id="rId34"/>
-    <p:sldId id="434" r:id="rId35"/>
-    <p:sldId id="435" r:id="rId36"/>
-    <p:sldId id="436" r:id="rId37"/>
-    <p:sldId id="438" r:id="rId38"/>
-    <p:sldId id="440" r:id="rId39"/>
-    <p:sldId id="441" r:id="rId40"/>
-    <p:sldId id="439" r:id="rId41"/>
+    <p:sldId id="418" r:id="rId21"/>
+    <p:sldId id="420" r:id="rId22"/>
+    <p:sldId id="421" r:id="rId23"/>
+    <p:sldId id="424" r:id="rId24"/>
+    <p:sldId id="425" r:id="rId25"/>
+    <p:sldId id="426" r:id="rId26"/>
+    <p:sldId id="427" r:id="rId27"/>
+    <p:sldId id="428" r:id="rId28"/>
+    <p:sldId id="429" r:id="rId29"/>
+    <p:sldId id="430" r:id="rId30"/>
+    <p:sldId id="431" r:id="rId31"/>
+    <p:sldId id="432" r:id="rId32"/>
+    <p:sldId id="433" r:id="rId33"/>
+    <p:sldId id="434" r:id="rId34"/>
   </p:sldIdLst>
   <p:sldSz cx="12192000" cy="6858000"/>
   <p:notesSz cx="7315200" cy="9601200"/>
@@ -672,7 +665,7 @@
           <a:p>
             <a:fld id="{241B16FF-F642-4C48-9DD1-6F6C6574ABC5}" type="datetimeFigureOut">
               <a:rPr lang="en-US" smtClean="0"/>
-              <a:t>10/2/2025</a:t>
+              <a:t>10/1/2026</a:t>
             </a:fld>
             <a:endParaRPr lang="en-US"/>
           </a:p>
@@ -904,7 +897,7 @@
           <a:p>
             <a:fld id="{241B16FF-F642-4C48-9DD1-6F6C6574ABC5}" type="datetimeFigureOut">
               <a:rPr lang="en-US" smtClean="0"/>
-              <a:t>10/2/2025</a:t>
+              <a:t>10/1/2026</a:t>
             </a:fld>
             <a:endParaRPr lang="en-US"/>
           </a:p>
@@ -1126,7 +1119,7 @@
           <a:p>
             <a:fld id="{241B16FF-F642-4C48-9DD1-6F6C6574ABC5}" type="datetimeFigureOut">
               <a:rPr lang="en-US" smtClean="0"/>
-              <a:t>10/2/2025</a:t>
+              <a:t>10/1/2026</a:t>
             </a:fld>
             <a:endParaRPr lang="en-US"/>
           </a:p>
@@ -1425,7 +1418,7 @@
           <a:p>
             <a:fld id="{241B16FF-F642-4C48-9DD1-6F6C6574ABC5}" type="datetimeFigureOut">
               <a:rPr lang="en-US" smtClean="0"/>
-              <a:t>10/2/2025</a:t>
+              <a:t>10/1/2026</a:t>
             </a:fld>
             <a:endParaRPr lang="en-US"/>
           </a:p>
@@ -1714,7 +1707,7 @@
           <a:p>
             <a:fld id="{241B16FF-F642-4C48-9DD1-6F6C6574ABC5}" type="datetimeFigureOut">
               <a:rPr lang="en-US" smtClean="0"/>
-              <a:t>10/2/2025</a:t>
+              <a:t>10/1/2026</a:t>
             </a:fld>
             <a:endParaRPr lang="en-US"/>
           </a:p>
@@ -2150,7 +2143,7 @@
           <a:p>
             <a:fld id="{241B16FF-F642-4C48-9DD1-6F6C6574ABC5}" type="datetimeFigureOut">
               <a:rPr lang="en-US" smtClean="0"/>
-              <a:t>10/2/2025</a:t>
+              <a:t>10/1/2026</a:t>
             </a:fld>
             <a:endParaRPr lang="en-US"/>
           </a:p>
@@ -2315,7 +2308,7 @@
           <a:p>
             <a:fld id="{241B16FF-F642-4C48-9DD1-6F6C6574ABC5}" type="datetimeFigureOut">
               <a:rPr lang="en-US" smtClean="0"/>
-              <a:t>10/2/2025</a:t>
+              <a:t>10/1/2026</a:t>
             </a:fld>
             <a:endParaRPr lang="en-US"/>
           </a:p>
@@ -2452,7 +2445,7 @@
           <a:p>
             <a:fld id="{241B16FF-F642-4C48-9DD1-6F6C6574ABC5}" type="datetimeFigureOut">
               <a:rPr lang="en-US" smtClean="0"/>
-              <a:t>10/2/2025</a:t>
+              <a:t>10/1/2026</a:t>
             </a:fld>
             <a:endParaRPr lang="en-US"/>
           </a:p>
@@ -2787,7 +2780,7 @@
           <a:p>
             <a:fld id="{241B16FF-F642-4C48-9DD1-6F6C6574ABC5}" type="datetimeFigureOut">
               <a:rPr lang="en-US" smtClean="0"/>
-              <a:t>10/2/2025</a:t>
+              <a:t>10/1/2026</a:t>
             </a:fld>
             <a:endParaRPr lang="en-US"/>
           </a:p>
@@ -3099,7 +3092,7 @@
           <a:p>
             <a:fld id="{241B16FF-F642-4C48-9DD1-6F6C6574ABC5}" type="datetimeFigureOut">
               <a:rPr lang="en-US" smtClean="0"/>
-              <a:t>10/2/2025</a:t>
+              <a:t>10/1/2026</a:t>
             </a:fld>
             <a:endParaRPr lang="en-US"/>
           </a:p>
@@ -6940,7 +6933,7 @@
           <p:cNvPr id="2" name="Title 1">
             <a:extLst>
               <a:ext uri="{FF2B5EF4-FFF2-40B4-BE49-F238E27FC236}">
-                <a16:creationId xmlns:a16="http://schemas.microsoft.com/office/drawing/2014/main" id="{DA059D9C-8988-DB55-6B60-586B2B56B5A3}"/>
+                <a16:creationId xmlns:a16="http://schemas.microsoft.com/office/drawing/2014/main" id="{65A02FDF-5C41-A689-192F-88518334A270}"/>
               </a:ext>
             </a:extLst>
           </p:cNvPr>
@@ -6958,7 +6951,7 @@
           <a:p>
             <a:r>
               <a:rPr lang="en-US" dirty="0"/>
-              <a:t>parameters</a:t>
+              <a:t>See column names</a:t>
             </a:r>
           </a:p>
         </p:txBody>
@@ -6968,7 +6961,7 @@
           <p:cNvPr id="3" name="Content Placeholder 2">
             <a:extLst>
               <a:ext uri="{FF2B5EF4-FFF2-40B4-BE49-F238E27FC236}">
-                <a16:creationId xmlns:a16="http://schemas.microsoft.com/office/drawing/2014/main" id="{425B5EC4-9BD7-95DC-AE4A-494AE51FC206}"/>
+                <a16:creationId xmlns:a16="http://schemas.microsoft.com/office/drawing/2014/main" id="{DC2AEE46-D50F-CD95-0250-0B1B59B8619C}"/>
               </a:ext>
             </a:extLst>
           </p:cNvPr>
@@ -6979,129 +6972,85 @@
             <p:ph idx="1"/>
           </p:nvPr>
         </p:nvSpPr>
-        <p:spPr/>
+        <p:spPr>
+          <a:xfrm>
+            <a:off x="838200" y="2823412"/>
+            <a:ext cx="10515600" cy="3864772"/>
+          </a:xfrm>
+        </p:spPr>
         <p:txBody>
           <a:bodyPr/>
           <a:lstStyle/>
           <a:p>
             <a:r>
               <a:rPr lang="en-US" dirty="0"/>
-              <a:t>A function can have multiple parameters. Parameters are just inputs </a:t>
-            </a:r>
-          </a:p>
-          <a:p>
-            <a:r>
-              <a:rPr lang="en-US" dirty="0"/>
-              <a:t>For example, we might have a function called: </a:t>
+              <a:t>A </a:t>
+            </a:r>
+            <a:r>
+              <a:rPr lang="en-US" dirty="0" err="1"/>
+              <a:t>DataFrame</a:t>
+            </a:r>
+            <a:r>
+              <a:rPr lang="en-US" dirty="0"/>
+              <a:t> is a table with rows and columns. </a:t>
+            </a:r>
+          </a:p>
+          <a:p>
+            <a:pPr lvl="1"/>
+            <a:r>
+              <a:rPr lang="en-US" dirty="0"/>
+              <a:t>Rows are observations and associated values</a:t>
+            </a:r>
+          </a:p>
+          <a:p>
+            <a:pPr lvl="1"/>
+            <a:r>
+              <a:rPr lang="en-US" dirty="0"/>
+              <a:t>Columns are the what is being measured</a:t>
             </a:r>
           </a:p>
           <a:p>
             <a:pPr marL="0" indent="0">
               <a:buNone/>
             </a:pPr>
-            <a:r>
-              <a:rPr lang="en-US" dirty="0"/>
-              <a:t>	</a:t>
-            </a:r>
-            <a:r>
-              <a:rPr lang="en-US" dirty="0" err="1">
-                <a:solidFill>
-                  <a:srgbClr val="FF0000"/>
-                </a:solidFill>
-              </a:rPr>
-              <a:t>divide_two_numbers</a:t>
-            </a:r>
-            <a:r>
-              <a:rPr lang="en-US" dirty="0">
-                <a:solidFill>
-                  <a:srgbClr val="FF0000"/>
-                </a:solidFill>
-              </a:rPr>
-              <a:t>(numerator, denominator)</a:t>
-            </a:r>
-          </a:p>
-          <a:p>
-            <a:r>
-              <a:rPr lang="en-US" dirty="0"/>
-              <a:t>We could call the function in the two following ways:</a:t>
-            </a:r>
-          </a:p>
-          <a:p>
-            <a:pPr marL="0" indent="0">
-              <a:buNone/>
-            </a:pPr>
-            <a:r>
-              <a:rPr lang="en-US" dirty="0"/>
-              <a:t>	</a:t>
-            </a:r>
-            <a:r>
-              <a:rPr lang="en-US" dirty="0" err="1">
-                <a:solidFill>
-                  <a:srgbClr val="FF0000"/>
-                </a:solidFill>
-              </a:rPr>
-              <a:t>divide_two_numbers</a:t>
-            </a:r>
-            <a:r>
-              <a:rPr lang="en-US" dirty="0">
-                <a:solidFill>
-                  <a:srgbClr val="FF0000"/>
-                </a:solidFill>
-              </a:rPr>
-              <a:t>(numerator=12, denominator=6)</a:t>
-            </a:r>
-          </a:p>
-          <a:p>
-            <a:pPr marL="0" indent="0">
-              <a:buNone/>
-            </a:pPr>
-            <a:r>
-              <a:rPr lang="en-US" dirty="0">
-                <a:solidFill>
-                  <a:srgbClr val="FF0000"/>
-                </a:solidFill>
-              </a:rPr>
-              <a:t>	</a:t>
-            </a:r>
-            <a:r>
-              <a:rPr lang="en-US" dirty="0" err="1">
-                <a:solidFill>
-                  <a:srgbClr val="FF0000"/>
-                </a:solidFill>
-              </a:rPr>
-              <a:t>divide_two_numbers</a:t>
-            </a:r>
-            <a:r>
-              <a:rPr lang="en-US" dirty="0">
-                <a:solidFill>
-                  <a:srgbClr val="FF0000"/>
-                </a:solidFill>
-              </a:rPr>
-              <a:t>(12, 6)</a:t>
-            </a:r>
-          </a:p>
-          <a:p>
-            <a:r>
-              <a:rPr lang="en-US" dirty="0"/>
-              <a:t>In the second version, uses ordering to figure out what you mean</a:t>
-            </a:r>
-          </a:p>
-          <a:p>
-            <a:pPr lvl="1"/>
-            <a:r>
-              <a:rPr lang="en-US" dirty="0"/>
-              <a:t>i.e. it assigns 12 to numerator and 6 to denominator</a:t>
-            </a:r>
-          </a:p>
-          <a:p>
             <a:endParaRPr lang="en-US" dirty="0"/>
           </a:p>
         </p:txBody>
       </p:sp>
+      <p:pic>
+        <p:nvPicPr>
+          <p:cNvPr id="9" name="Picture 8">
+            <a:extLst>
+              <a:ext uri="{FF2B5EF4-FFF2-40B4-BE49-F238E27FC236}">
+                <a16:creationId xmlns:a16="http://schemas.microsoft.com/office/drawing/2014/main" id="{EB37A11C-7E24-669B-EC49-DC361A9D1989}"/>
+              </a:ext>
+            </a:extLst>
+          </p:cNvPr>
+          <p:cNvPicPr>
+            <a:picLocks noChangeAspect="1"/>
+          </p:cNvPicPr>
+          <p:nvPr/>
+        </p:nvPicPr>
+        <p:blipFill>
+          <a:blip r:embed="rId2"/>
+          <a:stretch>
+            <a:fillRect/>
+          </a:stretch>
+        </p:blipFill>
+        <p:spPr>
+          <a:xfrm>
+            <a:off x="2849598" y="1179846"/>
+            <a:ext cx="6492803" cy="1402202"/>
+          </a:xfrm>
+          <a:prstGeom prst="rect">
+            <a:avLst/>
+          </a:prstGeom>
+        </p:spPr>
+      </p:pic>
     </p:spTree>
     <p:extLst>
       <p:ext uri="{BB962C8B-B14F-4D97-AF65-F5344CB8AC3E}">
-        <p14:creationId xmlns:p14="http://schemas.microsoft.com/office/powerpoint/2010/main" val="1830911744"/>
+        <p14:creationId xmlns:p14="http://schemas.microsoft.com/office/powerpoint/2010/main" val="2088713392"/>
       </p:ext>
     </p:extLst>
   </p:cSld>
@@ -7145,7 +7094,7 @@
           <p:cNvPr id="2" name="Title 1">
             <a:extLst>
               <a:ext uri="{FF2B5EF4-FFF2-40B4-BE49-F238E27FC236}">
-                <a16:creationId xmlns:a16="http://schemas.microsoft.com/office/drawing/2014/main" id="{65A02FDF-5C41-A689-192F-88518334A270}"/>
+                <a16:creationId xmlns:a16="http://schemas.microsoft.com/office/drawing/2014/main" id="{652519B5-5EC7-83F9-5119-143FA1A02240}"/>
               </a:ext>
             </a:extLst>
           </p:cNvPr>
@@ -7163,7 +7112,7 @@
           <a:p>
             <a:r>
               <a:rPr lang="en-US" dirty="0"/>
-              <a:t>See column names</a:t>
+              <a:t>See number of rows and columns</a:t>
             </a:r>
           </a:p>
         </p:txBody>
@@ -7173,7 +7122,7 @@
           <p:cNvPr id="3" name="Content Placeholder 2">
             <a:extLst>
               <a:ext uri="{FF2B5EF4-FFF2-40B4-BE49-F238E27FC236}">
-                <a16:creationId xmlns:a16="http://schemas.microsoft.com/office/drawing/2014/main" id="{DC2AEE46-D50F-CD95-0250-0B1B59B8619C}"/>
+                <a16:creationId xmlns:a16="http://schemas.microsoft.com/office/drawing/2014/main" id="{22B5F237-0F2D-E2C4-F912-17920E110284}"/>
               </a:ext>
             </a:extLst>
           </p:cNvPr>
@@ -7186,8 +7135,8 @@
         </p:nvSpPr>
         <p:spPr>
           <a:xfrm>
-            <a:off x="838200" y="2823412"/>
-            <a:ext cx="10515600" cy="3864772"/>
+            <a:off x="838200" y="2831432"/>
+            <a:ext cx="10515600" cy="3856751"/>
           </a:xfrm>
         </p:spPr>
         <p:txBody>
@@ -7196,36 +7145,20 @@
           <a:p>
             <a:r>
               <a:rPr lang="en-US" dirty="0"/>
-              <a:t>A </a:t>
-            </a:r>
-            <a:r>
-              <a:rPr lang="en-US" dirty="0" err="1"/>
-              <a:t>DataFrame</a:t>
-            </a:r>
-            <a:r>
-              <a:rPr lang="en-US" dirty="0"/>
-              <a:t> is a table with rows and columns. </a:t>
-            </a:r>
-          </a:p>
-          <a:p>
-            <a:pPr lvl="1"/>
-            <a:r>
-              <a:rPr lang="en-US" dirty="0"/>
-              <a:t>Rows are observations and associated values</a:t>
-            </a:r>
-          </a:p>
-          <a:p>
-            <a:pPr lvl="1"/>
-            <a:r>
-              <a:rPr lang="en-US" dirty="0"/>
-              <a:t>Columns are the what is being measured</a:t>
-            </a:r>
-          </a:p>
-          <a:p>
-            <a:pPr marL="0" indent="0">
-              <a:buNone/>
-            </a:pPr>
-            <a:endParaRPr lang="en-US" dirty="0"/>
+              <a:t>The “shape” property gives us this</a:t>
+            </a:r>
+          </a:p>
+          <a:p>
+            <a:r>
+              <a:rPr lang="en-US" dirty="0"/>
+              <a:t>The first number is the number of rows</a:t>
+            </a:r>
+          </a:p>
+          <a:p>
+            <a:r>
+              <a:rPr lang="en-US" dirty="0"/>
+              <a:t>The second number is the number of columns</a:t>
+            </a:r>
           </a:p>
         </p:txBody>
       </p:sp>
@@ -7234,7 +7167,7 @@
           <p:cNvPr id="9" name="Picture 8">
             <a:extLst>
               <a:ext uri="{FF2B5EF4-FFF2-40B4-BE49-F238E27FC236}">
-                <a16:creationId xmlns:a16="http://schemas.microsoft.com/office/drawing/2014/main" id="{EB37A11C-7E24-669B-EC49-DC361A9D1989}"/>
+                <a16:creationId xmlns:a16="http://schemas.microsoft.com/office/drawing/2014/main" id="{2F3DD806-6979-2771-843B-B06F26D2B6DB}"/>
               </a:ext>
             </a:extLst>
           </p:cNvPr>
@@ -7251,8 +7184,8 @@
         </p:blipFill>
         <p:spPr>
           <a:xfrm>
-            <a:off x="2849598" y="1179846"/>
-            <a:ext cx="6492803" cy="1402202"/>
+            <a:off x="5255739" y="1673151"/>
+            <a:ext cx="1295512" cy="944962"/>
           </a:xfrm>
           <a:prstGeom prst="rect">
             <a:avLst/>
@@ -7262,7 +7195,7 @@
     </p:spTree>
     <p:extLst>
       <p:ext uri="{BB962C8B-B14F-4D97-AF65-F5344CB8AC3E}">
-        <p14:creationId xmlns:p14="http://schemas.microsoft.com/office/powerpoint/2010/main" val="2088713392"/>
+        <p14:creationId xmlns:p14="http://schemas.microsoft.com/office/powerpoint/2010/main" val="686517489"/>
       </p:ext>
     </p:extLst>
   </p:cSld>
@@ -7324,7 +7257,7 @@
           <a:p>
             <a:r>
               <a:rPr lang="en-US" dirty="0"/>
-              <a:t>See number of rows and columns</a:t>
+              <a:t>Brackets []</a:t>
             </a:r>
           </a:p>
         </p:txBody>
@@ -7347,8 +7280,8 @@
         </p:nvSpPr>
         <p:spPr>
           <a:xfrm>
-            <a:off x="838200" y="2831432"/>
-            <a:ext cx="10515600" cy="3856751"/>
+            <a:off x="838200" y="1394592"/>
+            <a:ext cx="10515600" cy="5293591"/>
           </a:xfrm>
         </p:spPr>
         <p:txBody>
@@ -7357,57 +7290,127 @@
           <a:p>
             <a:r>
               <a:rPr lang="en-US" dirty="0"/>
-              <a:t>The “shape” property gives us this</a:t>
-            </a:r>
-          </a:p>
-          <a:p>
-            <a:r>
-              <a:rPr lang="en-US" dirty="0"/>
-              <a:t>The first number is the number of rows</a:t>
-            </a:r>
-          </a:p>
-          <a:p>
-            <a:r>
-              <a:rPr lang="en-US" dirty="0"/>
-              <a:t>The second number is the number of columns</a:t>
-            </a:r>
-          </a:p>
-        </p:txBody>
-      </p:sp>
-      <p:pic>
-        <p:nvPicPr>
-          <p:cNvPr id="9" name="Picture 8">
-            <a:extLst>
-              <a:ext uri="{FF2B5EF4-FFF2-40B4-BE49-F238E27FC236}">
-                <a16:creationId xmlns:a16="http://schemas.microsoft.com/office/drawing/2014/main" id="{2F3DD806-6979-2771-843B-B06F26D2B6DB}"/>
-              </a:ext>
-            </a:extLst>
-          </p:cNvPr>
-          <p:cNvPicPr>
-            <a:picLocks noChangeAspect="1"/>
-          </p:cNvPicPr>
-          <p:nvPr/>
-        </p:nvPicPr>
-        <p:blipFill>
-          <a:blip r:embed="rId2"/>
-          <a:stretch>
-            <a:fillRect/>
-          </a:stretch>
-        </p:blipFill>
-        <p:spPr>
-          <a:xfrm>
-            <a:off x="5255739" y="1673151"/>
-            <a:ext cx="1295512" cy="944962"/>
-          </a:xfrm>
-          <a:prstGeom prst="rect">
-            <a:avLst/>
-          </a:prstGeom>
-        </p:spPr>
-      </p:pic>
+              <a:t>In python, brackets are used to access parts of an object.</a:t>
+            </a:r>
+          </a:p>
+          <a:p>
+            <a:r>
+              <a:rPr lang="en-US" dirty="0"/>
+              <a:t>For example, let’s say we have the following line of code:</a:t>
+            </a:r>
+          </a:p>
+          <a:p>
+            <a:pPr marL="0" indent="0">
+              <a:buNone/>
+            </a:pPr>
+            <a:r>
+              <a:rPr lang="en-US" dirty="0" err="1">
+                <a:solidFill>
+                  <a:srgbClr val="FF0000"/>
+                </a:solidFill>
+              </a:rPr>
+              <a:t>my_list</a:t>
+            </a:r>
+            <a:r>
+              <a:rPr lang="en-US" dirty="0">
+                <a:solidFill>
+                  <a:srgbClr val="FF0000"/>
+                </a:solidFill>
+              </a:rPr>
+              <a:t> = [2, 5, 8]</a:t>
+            </a:r>
+          </a:p>
+          <a:p>
+            <a:r>
+              <a:rPr lang="en-US" dirty="0" err="1">
+                <a:solidFill>
+                  <a:srgbClr val="FF0000"/>
+                </a:solidFill>
+              </a:rPr>
+              <a:t>my_list</a:t>
+            </a:r>
+            <a:r>
+              <a:rPr lang="en-US" dirty="0"/>
+              <a:t> is a list with three elements</a:t>
+            </a:r>
+          </a:p>
+          <a:p>
+            <a:r>
+              <a:rPr lang="en-US" dirty="0"/>
+              <a:t>To access an element within </a:t>
+            </a:r>
+            <a:r>
+              <a:rPr lang="en-US" dirty="0" err="1">
+                <a:solidFill>
+                  <a:srgbClr val="FF0000"/>
+                </a:solidFill>
+              </a:rPr>
+              <a:t>my_list</a:t>
+            </a:r>
+            <a:r>
+              <a:rPr lang="en-US" dirty="0"/>
+              <a:t>, we would use the brackets:</a:t>
+            </a:r>
+          </a:p>
+          <a:p>
+            <a:pPr marL="0" indent="0">
+              <a:buNone/>
+            </a:pPr>
+            <a:r>
+              <a:rPr lang="en-US" dirty="0" err="1">
+                <a:solidFill>
+                  <a:srgbClr val="FF0000"/>
+                </a:solidFill>
+              </a:rPr>
+              <a:t>my_list</a:t>
+            </a:r>
+            <a:r>
+              <a:rPr lang="en-US" dirty="0">
+                <a:solidFill>
+                  <a:srgbClr val="FF0000"/>
+                </a:solidFill>
+              </a:rPr>
+              <a:t>[1]</a:t>
+            </a:r>
+          </a:p>
+          <a:p>
+            <a:r>
+              <a:rPr lang="en-US" dirty="0"/>
+              <a:t>Would access the second in the list, which is 5 </a:t>
+            </a:r>
+          </a:p>
+          <a:p>
+            <a:endParaRPr lang="en-US" dirty="0"/>
+          </a:p>
+          <a:p>
+            <a:r>
+              <a:rPr lang="en-US" dirty="0"/>
+              <a:t>So how would we find the number of rows for </a:t>
+            </a:r>
+            <a:r>
+              <a:rPr lang="en-US" dirty="0" err="1"/>
+              <a:t>df</a:t>
+            </a:r>
+            <a:r>
+              <a:rPr lang="en-US" dirty="0"/>
+              <a:t>?</a:t>
+            </a:r>
+          </a:p>
+          <a:p>
+            <a:pPr marL="0" indent="0">
+              <a:buNone/>
+            </a:pPr>
+            <a:endParaRPr lang="en-US" dirty="0"/>
+          </a:p>
+          <a:p>
+            <a:endParaRPr lang="en-US" dirty="0"/>
+          </a:p>
+        </p:txBody>
+      </p:sp>
     </p:spTree>
     <p:extLst>
       <p:ext uri="{BB962C8B-B14F-4D97-AF65-F5344CB8AC3E}">
-        <p14:creationId xmlns:p14="http://schemas.microsoft.com/office/powerpoint/2010/main" val="686517489"/>
+        <p14:creationId xmlns:p14="http://schemas.microsoft.com/office/powerpoint/2010/main" val="810173610"/>
       </p:ext>
     </p:extLst>
   </p:cSld>
@@ -7516,29 +7519,17 @@
               <a:buNone/>
             </a:pPr>
             <a:r>
-              <a:rPr lang="en-US" dirty="0" err="1">
-                <a:solidFill>
-                  <a:srgbClr val="FF0000"/>
-                </a:solidFill>
-              </a:rPr>
+              <a:rPr lang="en-US" dirty="0" err="1"/>
               <a:t>my_list</a:t>
             </a:r>
             <a:r>
-              <a:rPr lang="en-US" dirty="0">
-                <a:solidFill>
-                  <a:srgbClr val="FF0000"/>
-                </a:solidFill>
-              </a:rPr>
+              <a:rPr lang="en-US" dirty="0"/>
               <a:t> = [2, 5, 8]</a:t>
             </a:r>
           </a:p>
           <a:p>
             <a:r>
-              <a:rPr lang="en-US" dirty="0" err="1">
-                <a:solidFill>
-                  <a:srgbClr val="FF0000"/>
-                </a:solidFill>
-              </a:rPr>
+              <a:rPr lang="en-US" dirty="0" err="1"/>
               <a:t>my_list</a:t>
             </a:r>
             <a:r>
@@ -7552,11 +7543,7 @@
               <a:t>To access an element within </a:t>
             </a:r>
             <a:r>
-              <a:rPr lang="en-US" dirty="0" err="1">
-                <a:solidFill>
-                  <a:srgbClr val="FF0000"/>
-                </a:solidFill>
-              </a:rPr>
+              <a:rPr lang="en-US" dirty="0" err="1"/>
               <a:t>my_list</a:t>
             </a:r>
             <a:r>
@@ -7569,19 +7556,11 @@
               <a:buNone/>
             </a:pPr>
             <a:r>
-              <a:rPr lang="en-US" dirty="0" err="1">
-                <a:solidFill>
-                  <a:srgbClr val="FF0000"/>
-                </a:solidFill>
-              </a:rPr>
+              <a:rPr lang="en-US" dirty="0" err="1"/>
               <a:t>my_list</a:t>
             </a:r>
             <a:r>
-              <a:rPr lang="en-US" dirty="0">
-                <a:solidFill>
-                  <a:srgbClr val="FF0000"/>
-                </a:solidFill>
-              </a:rPr>
+              <a:rPr lang="en-US" dirty="0"/>
               <a:t>[1]</a:t>
             </a:r>
           </a:p>
@@ -7619,10 +7598,40 @@
           </a:p>
         </p:txBody>
       </p:sp>
+      <p:pic>
+        <p:nvPicPr>
+          <p:cNvPr id="4" name="Picture 3">
+            <a:extLst>
+              <a:ext uri="{FF2B5EF4-FFF2-40B4-BE49-F238E27FC236}">
+                <a16:creationId xmlns:a16="http://schemas.microsoft.com/office/drawing/2014/main" id="{03DD883D-8D6F-C210-CBE7-0CE172526514}"/>
+              </a:ext>
+            </a:extLst>
+          </p:cNvPr>
+          <p:cNvPicPr>
+            <a:picLocks noChangeAspect="1"/>
+          </p:cNvPicPr>
+          <p:nvPr/>
+        </p:nvPicPr>
+        <p:blipFill>
+          <a:blip r:embed="rId2"/>
+          <a:stretch>
+            <a:fillRect/>
+          </a:stretch>
+        </p:blipFill>
+        <p:spPr>
+          <a:xfrm>
+            <a:off x="8885022" y="5238708"/>
+            <a:ext cx="1386960" cy="952583"/>
+          </a:xfrm>
+          <a:prstGeom prst="rect">
+            <a:avLst/>
+          </a:prstGeom>
+        </p:spPr>
+      </p:pic>
     </p:spTree>
     <p:extLst>
       <p:ext uri="{BB962C8B-B14F-4D97-AF65-F5344CB8AC3E}">
-        <p14:creationId xmlns:p14="http://schemas.microsoft.com/office/powerpoint/2010/main" val="810173610"/>
+        <p14:creationId xmlns:p14="http://schemas.microsoft.com/office/powerpoint/2010/main" val="2399476320"/>
       </p:ext>
     </p:extLst>
   </p:cSld>
@@ -7666,7 +7675,7 @@
           <p:cNvPr id="2" name="Title 1">
             <a:extLst>
               <a:ext uri="{FF2B5EF4-FFF2-40B4-BE49-F238E27FC236}">
-                <a16:creationId xmlns:a16="http://schemas.microsoft.com/office/drawing/2014/main" id="{652519B5-5EC7-83F9-5119-143FA1A02240}"/>
+                <a16:creationId xmlns:a16="http://schemas.microsoft.com/office/drawing/2014/main" id="{9676CAA0-5606-6232-7BF6-DD50DEC12F08}"/>
               </a:ext>
             </a:extLst>
           </p:cNvPr>
@@ -7684,138 +7693,22 @@
           <a:p>
             <a:r>
               <a:rPr lang="en-US" dirty="0"/>
-              <a:t>Brackets []</a:t>
-            </a:r>
-          </a:p>
-        </p:txBody>
-      </p:sp>
-      <p:sp>
-        <p:nvSpPr>
-          <p:cNvPr id="3" name="Content Placeholder 2">
-            <a:extLst>
-              <a:ext uri="{FF2B5EF4-FFF2-40B4-BE49-F238E27FC236}">
-                <a16:creationId xmlns:a16="http://schemas.microsoft.com/office/drawing/2014/main" id="{22B5F237-0F2D-E2C4-F912-17920E110284}"/>
-              </a:ext>
-            </a:extLst>
-          </p:cNvPr>
-          <p:cNvSpPr>
-            <a:spLocks noGrp="1"/>
-          </p:cNvSpPr>
-          <p:nvPr>
-            <p:ph idx="1"/>
-          </p:nvPr>
-        </p:nvSpPr>
-        <p:spPr>
-          <a:xfrm>
-            <a:off x="838200" y="1394592"/>
-            <a:ext cx="10515600" cy="5293591"/>
-          </a:xfrm>
-        </p:spPr>
-        <p:txBody>
-          <a:bodyPr/>
-          <a:lstStyle/>
-          <a:p>
-            <a:r>
-              <a:rPr lang="en-US" dirty="0"/>
-              <a:t>In python, brackets are used to access parts of an object.</a:t>
-            </a:r>
-          </a:p>
-          <a:p>
-            <a:r>
-              <a:rPr lang="en-US" dirty="0"/>
-              <a:t>For example, let’s say we have the following line of code:</a:t>
-            </a:r>
-          </a:p>
-          <a:p>
-            <a:pPr marL="0" indent="0">
-              <a:buNone/>
-            </a:pPr>
+              <a:t>Seeing the first 5 rows in a </a:t>
+            </a:r>
             <a:r>
               <a:rPr lang="en-US" dirty="0" err="1"/>
-              <a:t>my_list</a:t>
-            </a:r>
-            <a:r>
-              <a:rPr lang="en-US" dirty="0"/>
-              <a:t> = [2, 5, 8]</a:t>
-            </a:r>
-          </a:p>
-          <a:p>
-            <a:r>
-              <a:rPr lang="en-US" dirty="0" err="1"/>
-              <a:t>my_list</a:t>
-            </a:r>
-            <a:r>
-              <a:rPr lang="en-US" dirty="0"/>
-              <a:t> is a list with three elements</a:t>
-            </a:r>
-          </a:p>
-          <a:p>
-            <a:r>
-              <a:rPr lang="en-US" dirty="0"/>
-              <a:t>To access an element within </a:t>
-            </a:r>
-            <a:r>
-              <a:rPr lang="en-US" dirty="0" err="1"/>
-              <a:t>my_list</a:t>
-            </a:r>
-            <a:r>
-              <a:rPr lang="en-US" dirty="0"/>
-              <a:t>, we would use the brackets:</a:t>
-            </a:r>
-          </a:p>
-          <a:p>
-            <a:pPr marL="0" indent="0">
-              <a:buNone/>
-            </a:pPr>
-            <a:r>
-              <a:rPr lang="en-US" dirty="0" err="1"/>
-              <a:t>my_list</a:t>
-            </a:r>
-            <a:r>
-              <a:rPr lang="en-US" dirty="0"/>
-              <a:t>[1]</a:t>
-            </a:r>
-          </a:p>
-          <a:p>
-            <a:r>
-              <a:rPr lang="en-US" dirty="0"/>
-              <a:t>Would access the second in the list, which is 5 </a:t>
-            </a:r>
-          </a:p>
-          <a:p>
-            <a:endParaRPr lang="en-US" dirty="0"/>
-          </a:p>
-          <a:p>
-            <a:r>
-              <a:rPr lang="en-US" dirty="0"/>
-              <a:t>So how would we find the number of rows for </a:t>
-            </a:r>
-            <a:r>
-              <a:rPr lang="en-US" dirty="0" err="1"/>
-              <a:t>df</a:t>
-            </a:r>
-            <a:r>
-              <a:rPr lang="en-US" dirty="0"/>
-              <a:t>?</a:t>
-            </a:r>
-          </a:p>
-          <a:p>
-            <a:pPr marL="0" indent="0">
-              <a:buNone/>
-            </a:pPr>
-            <a:endParaRPr lang="en-US" dirty="0"/>
-          </a:p>
-          <a:p>
+              <a:t>DataFrame</a:t>
+            </a:r>
             <a:endParaRPr lang="en-US" dirty="0"/>
           </a:p>
         </p:txBody>
       </p:sp>
       <p:pic>
         <p:nvPicPr>
-          <p:cNvPr id="4" name="Picture 3">
-            <a:extLst>
-              <a:ext uri="{FF2B5EF4-FFF2-40B4-BE49-F238E27FC236}">
-                <a16:creationId xmlns:a16="http://schemas.microsoft.com/office/drawing/2014/main" id="{03DD883D-8D6F-C210-CBE7-0CE172526514}"/>
+          <p:cNvPr id="7" name="Picture 6">
+            <a:extLst>
+              <a:ext uri="{FF2B5EF4-FFF2-40B4-BE49-F238E27FC236}">
+                <a16:creationId xmlns:a16="http://schemas.microsoft.com/office/drawing/2014/main" id="{E9E9808B-313A-EBF7-6F62-ED6F8926EC63}"/>
               </a:ext>
             </a:extLst>
           </p:cNvPr>
@@ -7832,8 +7725,8 @@
         </p:blipFill>
         <p:spPr>
           <a:xfrm>
-            <a:off x="8885022" y="5238708"/>
-            <a:ext cx="1386960" cy="952583"/>
+            <a:off x="1165432" y="1435232"/>
+            <a:ext cx="9861135" cy="3185436"/>
           </a:xfrm>
           <a:prstGeom prst="rect">
             <a:avLst/>
@@ -7843,7 +7736,7 @@
     </p:spTree>
     <p:extLst>
       <p:ext uri="{BB962C8B-B14F-4D97-AF65-F5344CB8AC3E}">
-        <p14:creationId xmlns:p14="http://schemas.microsoft.com/office/powerpoint/2010/main" val="2399476320"/>
+        <p14:creationId xmlns:p14="http://schemas.microsoft.com/office/powerpoint/2010/main" val="1675986077"/>
       </p:ext>
     </p:extLst>
   </p:cSld>
@@ -7905,7 +7798,7 @@
           <a:p>
             <a:r>
               <a:rPr lang="en-US" dirty="0"/>
-              <a:t>Seeing the first 5 rows in a </a:t>
+              <a:t>Seeing the first n rows in a </a:t>
             </a:r>
             <a:r>
               <a:rPr lang="en-US" dirty="0" err="1"/>
@@ -7915,12 +7808,74 @@
           </a:p>
         </p:txBody>
       </p:sp>
+      <p:sp>
+        <p:nvSpPr>
+          <p:cNvPr id="3" name="Content Placeholder 2">
+            <a:extLst>
+              <a:ext uri="{FF2B5EF4-FFF2-40B4-BE49-F238E27FC236}">
+                <a16:creationId xmlns:a16="http://schemas.microsoft.com/office/drawing/2014/main" id="{04EA393C-F380-1739-1333-8FC6806312BC}"/>
+              </a:ext>
+            </a:extLst>
+          </p:cNvPr>
+          <p:cNvSpPr>
+            <a:spLocks noGrp="1"/>
+          </p:cNvSpPr>
+          <p:nvPr>
+            <p:ph idx="1"/>
+          </p:nvPr>
+        </p:nvSpPr>
+        <p:spPr/>
+        <p:txBody>
+          <a:bodyPr/>
+          <a:lstStyle/>
+          <a:p>
+            <a:r>
+              <a:rPr lang="en-US" dirty="0"/>
+              <a:t>The head function has a parameter called “n”.</a:t>
+            </a:r>
+          </a:p>
+          <a:p>
+            <a:r>
+              <a:rPr lang="en-US" dirty="0"/>
+              <a:t>By default n=5, so when you are running </a:t>
+            </a:r>
+            <a:r>
+              <a:rPr lang="en-US" dirty="0" err="1"/>
+              <a:t>df.head</a:t>
+            </a:r>
+            <a:r>
+              <a:rPr lang="en-US" dirty="0"/>
+              <a:t>(), you are actually running </a:t>
+            </a:r>
+            <a:r>
+              <a:rPr lang="en-US" dirty="0" err="1"/>
+              <a:t>df.head</a:t>
+            </a:r>
+            <a:r>
+              <a:rPr lang="en-US" dirty="0"/>
+              <a:t>(n=5)</a:t>
+            </a:r>
+          </a:p>
+          <a:p>
+            <a:pPr marL="0" indent="0">
+              <a:buNone/>
+            </a:pPr>
+            <a:r>
+              <a:rPr lang="en-US" dirty="0"/>
+              <a:t> </a:t>
+            </a:r>
+          </a:p>
+          <a:p>
+            <a:endParaRPr lang="en-US" dirty="0"/>
+          </a:p>
+        </p:txBody>
+      </p:sp>
       <p:pic>
         <p:nvPicPr>
-          <p:cNvPr id="7" name="Picture 6">
-            <a:extLst>
-              <a:ext uri="{FF2B5EF4-FFF2-40B4-BE49-F238E27FC236}">
-                <a16:creationId xmlns:a16="http://schemas.microsoft.com/office/drawing/2014/main" id="{E9E9808B-313A-EBF7-6F62-ED6F8926EC63}"/>
+          <p:cNvPr id="8" name="Picture 7">
+            <a:extLst>
+              <a:ext uri="{FF2B5EF4-FFF2-40B4-BE49-F238E27FC236}">
+                <a16:creationId xmlns:a16="http://schemas.microsoft.com/office/drawing/2014/main" id="{DE2E251C-BB35-0932-28F2-F21FDCFCF882}"/>
               </a:ext>
             </a:extLst>
           </p:cNvPr>
@@ -7937,8 +7892,8 @@
         </p:blipFill>
         <p:spPr>
           <a:xfrm>
-            <a:off x="1165432" y="1435232"/>
-            <a:ext cx="9861135" cy="3185436"/>
+            <a:off x="1067178" y="3523765"/>
+            <a:ext cx="9784928" cy="1928027"/>
           </a:xfrm>
           <a:prstGeom prst="rect">
             <a:avLst/>
@@ -7948,7 +7903,7 @@
     </p:spTree>
     <p:extLst>
       <p:ext uri="{BB962C8B-B14F-4D97-AF65-F5344CB8AC3E}">
-        <p14:creationId xmlns:p14="http://schemas.microsoft.com/office/powerpoint/2010/main" val="1675986077"/>
+        <p14:creationId xmlns:p14="http://schemas.microsoft.com/office/powerpoint/2010/main" val="2058017095"/>
       </p:ext>
     </p:extLst>
   </p:cSld>
@@ -8010,13 +7965,8 @@
           <a:p>
             <a:r>
               <a:rPr lang="en-US" dirty="0"/>
-              <a:t>Seeing the first n rows in a </a:t>
-            </a:r>
-            <a:r>
-              <a:rPr lang="en-US" dirty="0" err="1"/>
-              <a:t>DataFrame</a:t>
-            </a:r>
-            <a:endParaRPr lang="en-US" dirty="0"/>
+              <a:t>Access the data in a column</a:t>
+            </a:r>
           </a:p>
         </p:txBody>
       </p:sp>
@@ -8036,49 +7986,26 @@
             <p:ph idx="1"/>
           </p:nvPr>
         </p:nvSpPr>
-        <p:spPr/>
+        <p:spPr>
+          <a:xfrm>
+            <a:off x="838200" y="1506582"/>
+            <a:ext cx="6204284" cy="5181601"/>
+          </a:xfrm>
+        </p:spPr>
         <p:txBody>
           <a:bodyPr/>
           <a:lstStyle/>
           <a:p>
             <a:r>
               <a:rPr lang="en-US" dirty="0"/>
-              <a:t>The head function has a parameter called “n”.</a:t>
-            </a:r>
-          </a:p>
-          <a:p>
-            <a:r>
-              <a:rPr lang="en-US" dirty="0"/>
-              <a:t>By default n=5, so when you are running </a:t>
-            </a:r>
-            <a:r>
-              <a:rPr lang="en-US" dirty="0" err="1"/>
-              <a:t>df.head</a:t>
-            </a:r>
-            <a:r>
-              <a:rPr lang="en-US" dirty="0"/>
-              <a:t>(), you are actually running </a:t>
-            </a:r>
-            <a:r>
-              <a:rPr lang="en-US" dirty="0" err="1"/>
-              <a:t>df.head</a:t>
-            </a:r>
-            <a:r>
-              <a:rPr lang="en-US" dirty="0"/>
-              <a:t>(n=5)</a:t>
-            </a:r>
-          </a:p>
-          <a:p>
-            <a:pPr marL="0" indent="0">
-              <a:buNone/>
-            </a:pPr>
-            <a:r>
-              <a:rPr lang="en-US" dirty="0"/>
-              <a:t> </a:t>
-            </a:r>
-          </a:p>
-          <a:p>
-            <a:endParaRPr lang="en-US" dirty="0"/>
+              <a:t>We want to access something, so we will use brackets.</a:t>
+            </a:r>
+          </a:p>
+          <a:p>
+            <a:r>
+              <a:rPr lang="en-US" dirty="0"/>
+              <a:t>In this case, we put the name of the column inside the brackets. </a:t>
+            </a:r>
           </a:p>
         </p:txBody>
       </p:sp>
@@ -8087,7 +8014,7 @@
           <p:cNvPr id="8" name="Picture 7">
             <a:extLst>
               <a:ext uri="{FF2B5EF4-FFF2-40B4-BE49-F238E27FC236}">
-                <a16:creationId xmlns:a16="http://schemas.microsoft.com/office/drawing/2014/main" id="{DE2E251C-BB35-0932-28F2-F21FDCFCF882}"/>
+                <a16:creationId xmlns:a16="http://schemas.microsoft.com/office/drawing/2014/main" id="{BF39D109-7633-D746-EAE4-31FF24228EB5}"/>
               </a:ext>
             </a:extLst>
           </p:cNvPr>
@@ -8104,8 +8031,8 @@
         </p:blipFill>
         <p:spPr>
           <a:xfrm>
-            <a:off x="1067178" y="3523765"/>
-            <a:ext cx="9784928" cy="1928027"/>
+            <a:off x="7147774" y="2534901"/>
+            <a:ext cx="4313294" cy="3520745"/>
           </a:xfrm>
           <a:prstGeom prst="rect">
             <a:avLst/>
@@ -8115,7 +8042,7 @@
     </p:spTree>
     <p:extLst>
       <p:ext uri="{BB962C8B-B14F-4D97-AF65-F5344CB8AC3E}">
-        <p14:creationId xmlns:p14="http://schemas.microsoft.com/office/powerpoint/2010/main" val="2058017095"/>
+        <p14:creationId xmlns:p14="http://schemas.microsoft.com/office/powerpoint/2010/main" val="3194700891"/>
       </p:ext>
     </p:extLst>
   </p:cSld>
@@ -8159,7 +8086,7 @@
           <p:cNvPr id="2" name="Title 1">
             <a:extLst>
               <a:ext uri="{FF2B5EF4-FFF2-40B4-BE49-F238E27FC236}">
-                <a16:creationId xmlns:a16="http://schemas.microsoft.com/office/drawing/2014/main" id="{9676CAA0-5606-6232-7BF6-DD50DEC12F08}"/>
+                <a16:creationId xmlns:a16="http://schemas.microsoft.com/office/drawing/2014/main" id="{6AF13056-372E-83DA-CEE7-73BA8E652B04}"/>
               </a:ext>
             </a:extLst>
           </p:cNvPr>
@@ -8177,7 +8104,7 @@
           <a:p>
             <a:r>
               <a:rPr lang="en-US" dirty="0"/>
-              <a:t>Access the data in a column</a:t>
+              <a:t>Example</a:t>
             </a:r>
           </a:p>
         </p:txBody>
@@ -8187,7 +8114,7 @@
           <p:cNvPr id="3" name="Content Placeholder 2">
             <a:extLst>
               <a:ext uri="{FF2B5EF4-FFF2-40B4-BE49-F238E27FC236}">
-                <a16:creationId xmlns:a16="http://schemas.microsoft.com/office/drawing/2014/main" id="{04EA393C-F380-1739-1333-8FC6806312BC}"/>
+                <a16:creationId xmlns:a16="http://schemas.microsoft.com/office/drawing/2014/main" id="{1365CA97-BB18-28E2-99ED-FB000C819916}"/>
               </a:ext>
             </a:extLst>
           </p:cNvPr>
@@ -8198,35 +8125,41 @@
             <p:ph idx="1"/>
           </p:nvPr>
         </p:nvSpPr>
-        <p:spPr>
-          <a:xfrm>
-            <a:off x="838200" y="1506582"/>
-            <a:ext cx="6204284" cy="5181601"/>
-          </a:xfrm>
-        </p:spPr>
+        <p:spPr/>
         <p:txBody>
           <a:bodyPr/>
           <a:lstStyle/>
           <a:p>
             <a:r>
               <a:rPr lang="en-US" dirty="0"/>
-              <a:t>We want to access something, so we will use brackets.</a:t>
-            </a:r>
-          </a:p>
-          <a:p>
-            <a:r>
-              <a:rPr lang="en-US" dirty="0"/>
-              <a:t>In this case, we put the name of the column inside the brackets. </a:t>
-            </a:r>
+              <a:t>Let’s combine assigning variables with accessing columns</a:t>
+            </a:r>
+          </a:p>
+          <a:p>
+            <a:r>
+              <a:rPr lang="en-US" dirty="0"/>
+              <a:t>Let’s create a variable called </a:t>
+            </a:r>
+            <a:r>
+              <a:rPr lang="en-US" dirty="0" err="1"/>
+              <a:t>yr</a:t>
+            </a:r>
+            <a:r>
+              <a:rPr lang="en-US" dirty="0"/>
+              <a:t> and set it equal to the text string “year”</a:t>
+            </a:r>
+          </a:p>
+          <a:p>
+            <a:endParaRPr lang="en-US" dirty="0"/>
           </a:p>
         </p:txBody>
       </p:sp>
       <p:pic>
         <p:nvPicPr>
-          <p:cNvPr id="8" name="Picture 7">
-            <a:extLst>
-              <a:ext uri="{FF2B5EF4-FFF2-40B4-BE49-F238E27FC236}">
-                <a16:creationId xmlns:a16="http://schemas.microsoft.com/office/drawing/2014/main" id="{BF39D109-7633-D746-EAE4-31FF24228EB5}"/>
+          <p:cNvPr id="7" name="Picture 6">
+            <a:extLst>
+              <a:ext uri="{FF2B5EF4-FFF2-40B4-BE49-F238E27FC236}">
+                <a16:creationId xmlns:a16="http://schemas.microsoft.com/office/drawing/2014/main" id="{7FE9E07A-16AE-0D4E-6A2F-46B905D8C934}"/>
               </a:ext>
             </a:extLst>
           </p:cNvPr>
@@ -8243,8 +8176,8 @@
         </p:blipFill>
         <p:spPr>
           <a:xfrm>
-            <a:off x="7147774" y="2534901"/>
-            <a:ext cx="4313294" cy="3520745"/>
+            <a:off x="4023180" y="2810614"/>
+            <a:ext cx="4145639" cy="3787468"/>
           </a:xfrm>
           <a:prstGeom prst="rect">
             <a:avLst/>
@@ -8254,7 +8187,7 @@
     </p:spTree>
     <p:extLst>
       <p:ext uri="{BB962C8B-B14F-4D97-AF65-F5344CB8AC3E}">
-        <p14:creationId xmlns:p14="http://schemas.microsoft.com/office/powerpoint/2010/main" val="3194700891"/>
+        <p14:creationId xmlns:p14="http://schemas.microsoft.com/office/powerpoint/2010/main" val="1723403613"/>
       </p:ext>
     </p:extLst>
   </p:cSld>
@@ -8298,7 +8231,7 @@
           <p:cNvPr id="2" name="Title 1">
             <a:extLst>
               <a:ext uri="{FF2B5EF4-FFF2-40B4-BE49-F238E27FC236}">
-                <a16:creationId xmlns:a16="http://schemas.microsoft.com/office/drawing/2014/main" id="{6AF13056-372E-83DA-CEE7-73BA8E652B04}"/>
+                <a16:creationId xmlns:a16="http://schemas.microsoft.com/office/drawing/2014/main" id="{F6395263-44EE-9334-C0AA-72BC9DB611D1}"/>
               </a:ext>
             </a:extLst>
           </p:cNvPr>
@@ -8316,7 +8249,7 @@
           <a:p>
             <a:r>
               <a:rPr lang="en-US" dirty="0"/>
-              <a:t>Example</a:t>
+              <a:t>Performing operations on columns</a:t>
             </a:r>
           </a:p>
         </p:txBody>
@@ -8326,7 +8259,7 @@
           <p:cNvPr id="3" name="Content Placeholder 2">
             <a:extLst>
               <a:ext uri="{FF2B5EF4-FFF2-40B4-BE49-F238E27FC236}">
-                <a16:creationId xmlns:a16="http://schemas.microsoft.com/office/drawing/2014/main" id="{1365CA97-BB18-28E2-99ED-FB000C819916}"/>
+                <a16:creationId xmlns:a16="http://schemas.microsoft.com/office/drawing/2014/main" id="{AAEEEF96-A609-F694-C900-552811039D27}"/>
               </a:ext>
             </a:extLst>
           </p:cNvPr>
@@ -8344,22 +8277,17 @@
           <a:p>
             <a:r>
               <a:rPr lang="en-US" dirty="0"/>
-              <a:t>Let’s combine assigning variables with accessing columns</a:t>
-            </a:r>
-          </a:p>
-          <a:p>
-            <a:r>
-              <a:rPr lang="en-US" dirty="0"/>
-              <a:t>Let’s create a variable called </a:t>
-            </a:r>
-            <a:r>
-              <a:rPr lang="en-US" dirty="0" err="1"/>
-              <a:t>yr</a:t>
-            </a:r>
-            <a:r>
-              <a:rPr lang="en-US" dirty="0"/>
-              <a:t> and set it equal to the text string “year”</a:t>
-            </a:r>
+              <a:t>“unique” gives us the unique values in a column</a:t>
+            </a:r>
+          </a:p>
+          <a:p>
+            <a:endParaRPr lang="en-US" dirty="0"/>
+          </a:p>
+          <a:p>
+            <a:endParaRPr lang="en-US" dirty="0"/>
+          </a:p>
+          <a:p>
+            <a:endParaRPr lang="en-US" dirty="0"/>
           </a:p>
           <a:p>
             <a:endParaRPr lang="en-US" dirty="0"/>
@@ -8368,10 +8296,10 @@
       </p:sp>
       <p:pic>
         <p:nvPicPr>
-          <p:cNvPr id="7" name="Picture 6">
-            <a:extLst>
-              <a:ext uri="{FF2B5EF4-FFF2-40B4-BE49-F238E27FC236}">
-                <a16:creationId xmlns:a16="http://schemas.microsoft.com/office/drawing/2014/main" id="{7FE9E07A-16AE-0D4E-6A2F-46B905D8C934}"/>
+          <p:cNvPr id="5" name="Picture 4">
+            <a:extLst>
+              <a:ext uri="{FF2B5EF4-FFF2-40B4-BE49-F238E27FC236}">
+                <a16:creationId xmlns:a16="http://schemas.microsoft.com/office/drawing/2014/main" id="{BF83A667-92ED-670D-5875-96419634B046}"/>
               </a:ext>
             </a:extLst>
           </p:cNvPr>
@@ -8388,8 +8316,38 @@
         </p:blipFill>
         <p:spPr>
           <a:xfrm>
-            <a:off x="4023180" y="2810614"/>
-            <a:ext cx="4145639" cy="3787468"/>
+            <a:off x="2720245" y="2382319"/>
+            <a:ext cx="2179509" cy="998307"/>
+          </a:xfrm>
+          <a:prstGeom prst="rect">
+            <a:avLst/>
+          </a:prstGeom>
+        </p:spPr>
+      </p:pic>
+      <p:pic>
+        <p:nvPicPr>
+          <p:cNvPr id="7" name="Picture 6">
+            <a:extLst>
+              <a:ext uri="{FF2B5EF4-FFF2-40B4-BE49-F238E27FC236}">
+                <a16:creationId xmlns:a16="http://schemas.microsoft.com/office/drawing/2014/main" id="{8AEF702F-9F39-D638-FCB3-B7FAFEF5C09A}"/>
+              </a:ext>
+            </a:extLst>
+          </p:cNvPr>
+          <p:cNvPicPr>
+            <a:picLocks noChangeAspect="1"/>
+          </p:cNvPicPr>
+          <p:nvPr/>
+        </p:nvPicPr>
+        <p:blipFill>
+          <a:blip r:embed="rId3"/>
+          <a:stretch>
+            <a:fillRect/>
+          </a:stretch>
+        </p:blipFill>
+        <p:spPr>
+          <a:xfrm>
+            <a:off x="6556921" y="2382319"/>
+            <a:ext cx="3139712" cy="983065"/>
           </a:xfrm>
           <a:prstGeom prst="rect">
             <a:avLst/>
@@ -8399,7 +8357,7 @@
     </p:spTree>
     <p:extLst>
       <p:ext uri="{BB962C8B-B14F-4D97-AF65-F5344CB8AC3E}">
-        <p14:creationId xmlns:p14="http://schemas.microsoft.com/office/powerpoint/2010/main" val="1723403613"/>
+        <p14:creationId xmlns:p14="http://schemas.microsoft.com/office/powerpoint/2010/main" val="46018838"/>
       </p:ext>
     </p:extLst>
   </p:cSld>
@@ -8502,6 +8460,35 @@
             <a:endParaRPr lang="en-US" dirty="0"/>
           </a:p>
           <a:p>
+            <a:r>
+              <a:rPr lang="en-US" dirty="0"/>
+              <a:t>“</a:t>
+            </a:r>
+            <a:r>
+              <a:rPr lang="en-US" dirty="0" err="1"/>
+              <a:t>nunique</a:t>
+            </a:r>
+            <a:r>
+              <a:rPr lang="en-US" dirty="0"/>
+              <a:t>” gives the number of unique values in a column</a:t>
+            </a:r>
+          </a:p>
+          <a:p>
+            <a:pPr marL="0" indent="0">
+              <a:buNone/>
+            </a:pPr>
+            <a:endParaRPr lang="en-US" dirty="0"/>
+          </a:p>
+          <a:p>
+            <a:endParaRPr lang="en-US" dirty="0"/>
+          </a:p>
+          <a:p>
+            <a:endParaRPr lang="en-US" dirty="0"/>
+          </a:p>
+          <a:p>
+            <a:endParaRPr lang="en-US" dirty="0"/>
+          </a:p>
+          <a:p>
             <a:endParaRPr lang="en-US" dirty="0"/>
           </a:p>
         </p:txBody>
@@ -8528,7 +8515,7 @@
         </p:blipFill>
         <p:spPr>
           <a:xfrm>
-            <a:off x="2720245" y="2382319"/>
+            <a:off x="2904729" y="2215572"/>
             <a:ext cx="2179509" cy="998307"/>
           </a:xfrm>
           <a:prstGeom prst="rect">
@@ -8538,10 +8525,10 @@
       </p:pic>
       <p:pic>
         <p:nvPicPr>
-          <p:cNvPr id="7" name="Picture 6">
-            <a:extLst>
-              <a:ext uri="{FF2B5EF4-FFF2-40B4-BE49-F238E27FC236}">
-                <a16:creationId xmlns:a16="http://schemas.microsoft.com/office/drawing/2014/main" id="{8AEF702F-9F39-D638-FCB3-B7FAFEF5C09A}"/>
+          <p:cNvPr id="6" name="Picture 5">
+            <a:extLst>
+              <a:ext uri="{FF2B5EF4-FFF2-40B4-BE49-F238E27FC236}">
+                <a16:creationId xmlns:a16="http://schemas.microsoft.com/office/drawing/2014/main" id="{8F042C77-4BD5-6657-47D0-BA885FDD6B19}"/>
               </a:ext>
             </a:extLst>
           </p:cNvPr>
@@ -8558,8 +8545,68 @@
         </p:blipFill>
         <p:spPr>
           <a:xfrm>
-            <a:off x="6556921" y="2382319"/>
+            <a:off x="2904729" y="4554150"/>
+            <a:ext cx="2232853" cy="914479"/>
+          </a:xfrm>
+          <a:prstGeom prst="rect">
+            <a:avLst/>
+          </a:prstGeom>
+        </p:spPr>
+      </p:pic>
+      <p:pic>
+        <p:nvPicPr>
+          <p:cNvPr id="10" name="Picture 9">
+            <a:extLst>
+              <a:ext uri="{FF2B5EF4-FFF2-40B4-BE49-F238E27FC236}">
+                <a16:creationId xmlns:a16="http://schemas.microsoft.com/office/drawing/2014/main" id="{45DDDB82-6093-6BD0-F196-EA00845304F7}"/>
+              </a:ext>
+            </a:extLst>
+          </p:cNvPr>
+          <p:cNvPicPr>
+            <a:picLocks noChangeAspect="1"/>
+          </p:cNvPicPr>
+          <p:nvPr/>
+        </p:nvPicPr>
+        <p:blipFill>
+          <a:blip r:embed="rId4"/>
+          <a:stretch>
+            <a:fillRect/>
+          </a:stretch>
+        </p:blipFill>
+        <p:spPr>
+          <a:xfrm>
+            <a:off x="6916417" y="2215572"/>
             <a:ext cx="3139712" cy="983065"/>
+          </a:xfrm>
+          <a:prstGeom prst="rect">
+            <a:avLst/>
+          </a:prstGeom>
+        </p:spPr>
+      </p:pic>
+      <p:pic>
+        <p:nvPicPr>
+          <p:cNvPr id="12" name="Picture 11">
+            <a:extLst>
+              <a:ext uri="{FF2B5EF4-FFF2-40B4-BE49-F238E27FC236}">
+                <a16:creationId xmlns:a16="http://schemas.microsoft.com/office/drawing/2014/main" id="{FD35EAC5-9F80-A930-49D9-49D092A2360D}"/>
+              </a:ext>
+            </a:extLst>
+          </p:cNvPr>
+          <p:cNvPicPr>
+            <a:picLocks noChangeAspect="1"/>
+          </p:cNvPicPr>
+          <p:nvPr/>
+        </p:nvPicPr>
+        <p:blipFill>
+          <a:blip r:embed="rId5"/>
+          <a:stretch>
+            <a:fillRect/>
+          </a:stretch>
+        </p:blipFill>
+        <p:spPr>
+          <a:xfrm>
+            <a:off x="6916417" y="4538872"/>
+            <a:ext cx="3269263" cy="876376"/>
           </a:xfrm>
           <a:prstGeom prst="rect">
             <a:avLst/>
@@ -8569,7 +8616,7 @@
     </p:spTree>
     <p:extLst>
       <p:ext uri="{BB962C8B-B14F-4D97-AF65-F5344CB8AC3E}">
-        <p14:creationId xmlns:p14="http://schemas.microsoft.com/office/powerpoint/2010/main" val="46018838"/>
+        <p14:creationId xmlns:p14="http://schemas.microsoft.com/office/powerpoint/2010/main" val="858787315"/>
       </p:ext>
     </p:extLst>
   </p:cSld>
@@ -8772,7 +8819,7 @@
           <p:cNvPr id="2" name="Title 1">
             <a:extLst>
               <a:ext uri="{FF2B5EF4-FFF2-40B4-BE49-F238E27FC236}">
-                <a16:creationId xmlns:a16="http://schemas.microsoft.com/office/drawing/2014/main" id="{F6395263-44EE-9334-C0AA-72BC9DB611D1}"/>
+                <a16:creationId xmlns:a16="http://schemas.microsoft.com/office/drawing/2014/main" id="{2FCA9F5D-5519-D502-119D-1A0B8EB48A56}"/>
               </a:ext>
             </a:extLst>
           </p:cNvPr>
@@ -8789,8 +8836,12 @@
           <a:lstStyle/>
           <a:p>
             <a:r>
-              <a:rPr lang="en-US" dirty="0"/>
-              <a:t>Performing operations on columns</a:t>
+              <a:rPr lang="en-US" dirty="0" err="1"/>
+              <a:t>value_counts</a:t>
+            </a:r>
+            <a:r>
+              <a:rPr lang="en-US" dirty="0"/>
+              <a:t>()</a:t>
             </a:r>
           </a:p>
         </p:txBody>
@@ -8800,7 +8851,7 @@
           <p:cNvPr id="3" name="Content Placeholder 2">
             <a:extLst>
               <a:ext uri="{FF2B5EF4-FFF2-40B4-BE49-F238E27FC236}">
-                <a16:creationId xmlns:a16="http://schemas.microsoft.com/office/drawing/2014/main" id="{AAEEEF96-A609-F694-C900-552811039D27}"/>
+                <a16:creationId xmlns:a16="http://schemas.microsoft.com/office/drawing/2014/main" id="{2BB31935-727E-76A2-B67B-A648CFB000EF}"/>
               </a:ext>
             </a:extLst>
           </p:cNvPr>
@@ -8818,30 +8869,24 @@
           <a:p>
             <a:r>
               <a:rPr lang="en-US" dirty="0"/>
-              <a:t>“unique” gives us the unique values in a column</a:t>
+              <a:t>What if we want to know the number of times each unique value appears in a column?</a:t>
             </a:r>
           </a:p>
           <a:p>
             <a:endParaRPr lang="en-US" dirty="0"/>
           </a:p>
           <a:p>
-            <a:endParaRPr lang="en-US" dirty="0"/>
-          </a:p>
-          <a:p>
-            <a:endParaRPr lang="en-US" dirty="0"/>
-          </a:p>
-          <a:p>
-            <a:r>
-              <a:rPr lang="en-US" dirty="0"/>
-              <a:t>“</a:t>
+            <a:r>
+              <a:rPr lang="en-US" dirty="0"/>
+              <a:t>We use the </a:t>
             </a:r>
             <a:r>
               <a:rPr lang="en-US" dirty="0" err="1"/>
-              <a:t>nunique</a:t>
-            </a:r>
-            <a:r>
-              <a:rPr lang="en-US" dirty="0"/>
-              <a:t>” gives the number of unique values in a column</a:t>
+              <a:t>value_counts</a:t>
+            </a:r>
+            <a:r>
+              <a:rPr lang="en-US" dirty="0"/>
+              <a:t>() function</a:t>
             </a:r>
           </a:p>
           <a:p>
@@ -8850,18 +8895,6 @@
             </a:pPr>
             <a:endParaRPr lang="en-US" dirty="0"/>
           </a:p>
-          <a:p>
-            <a:endParaRPr lang="en-US" dirty="0"/>
-          </a:p>
-          <a:p>
-            <a:endParaRPr lang="en-US" dirty="0"/>
-          </a:p>
-          <a:p>
-            <a:endParaRPr lang="en-US" dirty="0"/>
-          </a:p>
-          <a:p>
-            <a:endParaRPr lang="en-US" dirty="0"/>
-          </a:p>
         </p:txBody>
       </p:sp>
       <p:pic>
@@ -8869,7 +8902,7 @@
           <p:cNvPr id="5" name="Picture 4">
             <a:extLst>
               <a:ext uri="{FF2B5EF4-FFF2-40B4-BE49-F238E27FC236}">
-                <a16:creationId xmlns:a16="http://schemas.microsoft.com/office/drawing/2014/main" id="{BF83A667-92ED-670D-5875-96419634B046}"/>
+                <a16:creationId xmlns:a16="http://schemas.microsoft.com/office/drawing/2014/main" id="{DB184A12-92C0-7210-1EE2-BFD666EBD741}"/>
               </a:ext>
             </a:extLst>
           </p:cNvPr>
@@ -8886,98 +8919,8 @@
         </p:blipFill>
         <p:spPr>
           <a:xfrm>
-            <a:off x="2904729" y="2215572"/>
-            <a:ext cx="2179509" cy="998307"/>
-          </a:xfrm>
-          <a:prstGeom prst="rect">
-            <a:avLst/>
-          </a:prstGeom>
-        </p:spPr>
-      </p:pic>
-      <p:pic>
-        <p:nvPicPr>
-          <p:cNvPr id="6" name="Picture 5">
-            <a:extLst>
-              <a:ext uri="{FF2B5EF4-FFF2-40B4-BE49-F238E27FC236}">
-                <a16:creationId xmlns:a16="http://schemas.microsoft.com/office/drawing/2014/main" id="{8F042C77-4BD5-6657-47D0-BA885FDD6B19}"/>
-              </a:ext>
-            </a:extLst>
-          </p:cNvPr>
-          <p:cNvPicPr>
-            <a:picLocks noChangeAspect="1"/>
-          </p:cNvPicPr>
-          <p:nvPr/>
-        </p:nvPicPr>
-        <p:blipFill>
-          <a:blip r:embed="rId3"/>
-          <a:stretch>
-            <a:fillRect/>
-          </a:stretch>
-        </p:blipFill>
-        <p:spPr>
-          <a:xfrm>
-            <a:off x="2904729" y="4554150"/>
-            <a:ext cx="2232853" cy="914479"/>
-          </a:xfrm>
-          <a:prstGeom prst="rect">
-            <a:avLst/>
-          </a:prstGeom>
-        </p:spPr>
-      </p:pic>
-      <p:pic>
-        <p:nvPicPr>
-          <p:cNvPr id="10" name="Picture 9">
-            <a:extLst>
-              <a:ext uri="{FF2B5EF4-FFF2-40B4-BE49-F238E27FC236}">
-                <a16:creationId xmlns:a16="http://schemas.microsoft.com/office/drawing/2014/main" id="{45DDDB82-6093-6BD0-F196-EA00845304F7}"/>
-              </a:ext>
-            </a:extLst>
-          </p:cNvPr>
-          <p:cNvPicPr>
-            <a:picLocks noChangeAspect="1"/>
-          </p:cNvPicPr>
-          <p:nvPr/>
-        </p:nvPicPr>
-        <p:blipFill>
-          <a:blip r:embed="rId4"/>
-          <a:stretch>
-            <a:fillRect/>
-          </a:stretch>
-        </p:blipFill>
-        <p:spPr>
-          <a:xfrm>
-            <a:off x="6916417" y="2215572"/>
-            <a:ext cx="3139712" cy="983065"/>
-          </a:xfrm>
-          <a:prstGeom prst="rect">
-            <a:avLst/>
-          </a:prstGeom>
-        </p:spPr>
-      </p:pic>
-      <p:pic>
-        <p:nvPicPr>
-          <p:cNvPr id="12" name="Picture 11">
-            <a:extLst>
-              <a:ext uri="{FF2B5EF4-FFF2-40B4-BE49-F238E27FC236}">
-                <a16:creationId xmlns:a16="http://schemas.microsoft.com/office/drawing/2014/main" id="{FD35EAC5-9F80-A930-49D9-49D092A2360D}"/>
-              </a:ext>
-            </a:extLst>
-          </p:cNvPr>
-          <p:cNvPicPr>
-            <a:picLocks noChangeAspect="1"/>
-          </p:cNvPicPr>
-          <p:nvPr/>
-        </p:nvPicPr>
-        <p:blipFill>
-          <a:blip r:embed="rId5"/>
-          <a:stretch>
-            <a:fillRect/>
-          </a:stretch>
-        </p:blipFill>
-        <p:spPr>
-          <a:xfrm>
-            <a:off x="6916417" y="4538872"/>
-            <a:ext cx="3269263" cy="876376"/>
+            <a:off x="4096417" y="3918412"/>
+            <a:ext cx="3116850" cy="1684166"/>
           </a:xfrm>
           <a:prstGeom prst="rect">
             <a:avLst/>
@@ -8987,7 +8930,7 @@
     </p:spTree>
     <p:extLst>
       <p:ext uri="{BB962C8B-B14F-4D97-AF65-F5344CB8AC3E}">
-        <p14:creationId xmlns:p14="http://schemas.microsoft.com/office/powerpoint/2010/main" val="858787315"/>
+        <p14:creationId xmlns:p14="http://schemas.microsoft.com/office/powerpoint/2010/main" val="381048523"/>
       </p:ext>
     </p:extLst>
   </p:cSld>
@@ -9031,7 +8974,7 @@
           <p:cNvPr id="2" name="Title 1">
             <a:extLst>
               <a:ext uri="{FF2B5EF4-FFF2-40B4-BE49-F238E27FC236}">
-                <a16:creationId xmlns:a16="http://schemas.microsoft.com/office/drawing/2014/main" id="{2FCA9F5D-5519-D502-119D-1A0B8EB48A56}"/>
+                <a16:creationId xmlns:a16="http://schemas.microsoft.com/office/drawing/2014/main" id="{244A05F6-D7A4-180B-668D-FEDC4E79324A}"/>
               </a:ext>
             </a:extLst>
           </p:cNvPr>
@@ -9048,12 +8991,8 @@
           <a:lstStyle/>
           <a:p>
             <a:r>
-              <a:rPr lang="en-US" dirty="0" err="1"/>
-              <a:t>value_counts</a:t>
-            </a:r>
-            <a:r>
-              <a:rPr lang="en-US" dirty="0"/>
-              <a:t>()</a:t>
+              <a:rPr lang="en-US" dirty="0"/>
+              <a:t>The “normalize” parameter</a:t>
             </a:r>
           </a:p>
         </p:txBody>
@@ -9063,7 +9002,7 @@
           <p:cNvPr id="3" name="Content Placeholder 2">
             <a:extLst>
               <a:ext uri="{FF2B5EF4-FFF2-40B4-BE49-F238E27FC236}">
-                <a16:creationId xmlns:a16="http://schemas.microsoft.com/office/drawing/2014/main" id="{2BB31935-727E-76A2-B67B-A648CFB000EF}"/>
+                <a16:creationId xmlns:a16="http://schemas.microsoft.com/office/drawing/2014/main" id="{909D1F15-1577-2193-AC89-A316DDBD568C}"/>
               </a:ext>
             </a:extLst>
           </p:cNvPr>
@@ -9081,40 +9020,56 @@
           <a:p>
             <a:r>
               <a:rPr lang="en-US" dirty="0"/>
-              <a:t>What if we want to know the number of times each unique value appears in a column?</a:t>
-            </a:r>
-          </a:p>
-          <a:p>
-            <a:endParaRPr lang="en-US" dirty="0"/>
-          </a:p>
-          <a:p>
-            <a:r>
-              <a:rPr lang="en-US" dirty="0"/>
-              <a:t>We use the </a:t>
+              <a:t>An important parameter for </a:t>
+            </a:r>
+            <a:r>
+              <a:rPr lang="en-US" b="1" dirty="0" err="1"/>
+              <a:t>value</a:t>
             </a:r>
             <a:r>
               <a:rPr lang="en-US" dirty="0" err="1"/>
-              <a:t>value_counts</a:t>
-            </a:r>
-            <a:r>
-              <a:rPr lang="en-US" dirty="0"/>
-              <a:t>() function</a:t>
-            </a:r>
-          </a:p>
-          <a:p>
-            <a:pPr marL="0" indent="0">
-              <a:buNone/>
-            </a:pPr>
+              <a:t>_</a:t>
+            </a:r>
+            <a:r>
+              <a:rPr lang="en-US" b="1" dirty="0" err="1"/>
+              <a:t>counts</a:t>
+            </a:r>
+            <a:r>
+              <a:rPr lang="en-US" dirty="0"/>
+              <a:t> is </a:t>
+            </a:r>
+            <a:r>
+              <a:rPr lang="en-US" b="1" dirty="0"/>
+              <a:t>normalize</a:t>
+            </a:r>
+            <a:r>
+              <a:rPr lang="en-US" dirty="0"/>
+              <a:t> and the default value is </a:t>
+            </a:r>
+            <a:r>
+              <a:rPr lang="en-US" b="1" dirty="0"/>
+              <a:t>False</a:t>
+            </a:r>
+          </a:p>
+          <a:p>
+            <a:r>
+              <a:rPr lang="en-US" dirty="0"/>
+              <a:t>Normalizing here means to divide the count of each unique value by the number of rows in the </a:t>
+            </a:r>
+            <a:r>
+              <a:rPr lang="en-US" dirty="0" err="1"/>
+              <a:t>DataFrame</a:t>
+            </a:r>
             <a:endParaRPr lang="en-US" dirty="0"/>
           </a:p>
         </p:txBody>
       </p:sp>
       <p:pic>
         <p:nvPicPr>
-          <p:cNvPr id="5" name="Picture 4">
-            <a:extLst>
-              <a:ext uri="{FF2B5EF4-FFF2-40B4-BE49-F238E27FC236}">
-                <a16:creationId xmlns:a16="http://schemas.microsoft.com/office/drawing/2014/main" id="{DB184A12-92C0-7210-1EE2-BFD666EBD741}"/>
+          <p:cNvPr id="4" name="Picture 3">
+            <a:extLst>
+              <a:ext uri="{FF2B5EF4-FFF2-40B4-BE49-F238E27FC236}">
+                <a16:creationId xmlns:a16="http://schemas.microsoft.com/office/drawing/2014/main" id="{C4649906-563E-C73A-29CB-FE99C531BA36}"/>
               </a:ext>
             </a:extLst>
           </p:cNvPr>
@@ -9131,8 +9086,38 @@
         </p:blipFill>
         <p:spPr>
           <a:xfrm>
-            <a:off x="4096417" y="3918412"/>
+            <a:off x="1754270" y="3982580"/>
             <a:ext cx="3116850" cy="1684166"/>
+          </a:xfrm>
+          <a:prstGeom prst="rect">
+            <a:avLst/>
+          </a:prstGeom>
+        </p:spPr>
+      </p:pic>
+      <p:pic>
+        <p:nvPicPr>
+          <p:cNvPr id="6" name="Picture 5">
+            <a:extLst>
+              <a:ext uri="{FF2B5EF4-FFF2-40B4-BE49-F238E27FC236}">
+                <a16:creationId xmlns:a16="http://schemas.microsoft.com/office/drawing/2014/main" id="{8069EE7F-3ADD-BCF5-DA33-8BC0EF2C17DE}"/>
+              </a:ext>
+            </a:extLst>
+          </p:cNvPr>
+          <p:cNvPicPr>
+            <a:picLocks noChangeAspect="1"/>
+          </p:cNvPicPr>
+          <p:nvPr/>
+        </p:nvPicPr>
+        <p:blipFill>
+          <a:blip r:embed="rId3"/>
+          <a:stretch>
+            <a:fillRect/>
+          </a:stretch>
+        </p:blipFill>
+        <p:spPr>
+          <a:xfrm>
+            <a:off x="6185041" y="3982580"/>
+            <a:ext cx="4458086" cy="1653683"/>
           </a:xfrm>
           <a:prstGeom prst="rect">
             <a:avLst/>
@@ -9142,7 +9127,7 @@
     </p:spTree>
     <p:extLst>
       <p:ext uri="{BB962C8B-B14F-4D97-AF65-F5344CB8AC3E}">
-        <p14:creationId xmlns:p14="http://schemas.microsoft.com/office/powerpoint/2010/main" val="381048523"/>
+        <p14:creationId xmlns:p14="http://schemas.microsoft.com/office/powerpoint/2010/main" val="165987618"/>
       </p:ext>
     </p:extLst>
   </p:cSld>
@@ -9186,7 +9171,7 @@
           <p:cNvPr id="2" name="Title 1">
             <a:extLst>
               <a:ext uri="{FF2B5EF4-FFF2-40B4-BE49-F238E27FC236}">
-                <a16:creationId xmlns:a16="http://schemas.microsoft.com/office/drawing/2014/main" id="{244A05F6-D7A4-180B-668D-FEDC4E79324A}"/>
+                <a16:creationId xmlns:a16="http://schemas.microsoft.com/office/drawing/2014/main" id="{E7ACD6AE-8BC7-CBA0-ECF3-6BDC6486E270}"/>
               </a:ext>
             </a:extLst>
           </p:cNvPr>
@@ -9204,7 +9189,7 @@
           <a:p>
             <a:r>
               <a:rPr lang="en-US" dirty="0"/>
-              <a:t>The “normalize” parameter</a:t>
+              <a:t>Other common functions on columns</a:t>
             </a:r>
           </a:p>
         </p:txBody>
@@ -9214,7 +9199,7 @@
           <p:cNvPr id="3" name="Content Placeholder 2">
             <a:extLst>
               <a:ext uri="{FF2B5EF4-FFF2-40B4-BE49-F238E27FC236}">
-                <a16:creationId xmlns:a16="http://schemas.microsoft.com/office/drawing/2014/main" id="{909D1F15-1577-2193-AC89-A316DDBD568C}"/>
+                <a16:creationId xmlns:a16="http://schemas.microsoft.com/office/drawing/2014/main" id="{1D5F2DE6-6409-9194-5C91-FE26930FB48B}"/>
               </a:ext>
             </a:extLst>
           </p:cNvPr>
@@ -9232,56 +9217,34 @@
           <a:p>
             <a:r>
               <a:rPr lang="en-US" dirty="0"/>
-              <a:t>An important parameter for </a:t>
-            </a:r>
-            <a:r>
-              <a:rPr lang="en-US" b="1" dirty="0" err="1"/>
-              <a:t>value</a:t>
-            </a:r>
-            <a:r>
-              <a:rPr lang="en-US" dirty="0" err="1"/>
-              <a:t>_</a:t>
-            </a:r>
-            <a:r>
-              <a:rPr lang="en-US" b="1" dirty="0" err="1"/>
-              <a:t>counts</a:t>
-            </a:r>
-            <a:r>
-              <a:rPr lang="en-US" dirty="0"/>
-              <a:t> is </a:t>
+              <a:t>We use </a:t>
             </a:r>
             <a:r>
               <a:rPr lang="en-US" b="1" dirty="0"/>
-              <a:t>normalize</a:t>
-            </a:r>
-            <a:r>
-              <a:rPr lang="en-US" dirty="0"/>
-              <a:t> and the default value is </a:t>
-            </a:r>
-            <a:r>
-              <a:rPr lang="en-US" b="1" dirty="0"/>
-              <a:t>False</a:t>
-            </a:r>
-          </a:p>
-          <a:p>
-            <a:r>
-              <a:rPr lang="en-US" dirty="0"/>
-              <a:t>Normalizing here means to divide the count of each unique value by the number of rows in the </a:t>
-            </a:r>
-            <a:r>
-              <a:rPr lang="en-US" dirty="0" err="1"/>
-              <a:t>DataFrame</a:t>
-            </a:r>
+              <a:t>sum </a:t>
+            </a:r>
+            <a:r>
+              <a:rPr lang="en-US" dirty="0"/>
+              <a:t>to add up all of the values in a column</a:t>
+            </a:r>
+          </a:p>
+          <a:p>
+            <a:endParaRPr lang="en-US" b="1" dirty="0"/>
+          </a:p>
+          <a:p>
+            <a:pPr marL="0" indent="0">
+              <a:buNone/>
+            </a:pPr>
             <a:endParaRPr lang="en-US" dirty="0"/>
           </a:p>
         </p:txBody>
       </p:sp>
       <p:pic>
         <p:nvPicPr>
-          <p:cNvPr id="4" name="Picture 3">
-            <a:extLst>
-              <a:ext uri="{FF2B5EF4-FFF2-40B4-BE49-F238E27FC236}">
-                <a16:creationId xmlns:a16="http://schemas.microsoft.com/office/drawing/2014/main" id="{C4649906-563E-C73A-29CB-FE99C531BA36}"/>
+          <p:cNvPr id="5" name="Picture 4">
+            <a:extLst>
+              <a:ext uri="{FF2B5EF4-FFF2-40B4-BE49-F238E27FC236}">
+                <a16:creationId xmlns:a16="http://schemas.microsoft.com/office/drawing/2014/main" id="{BD09B149-8511-7EA6-2166-588F352831FC}"/>
               </a:ext>
             </a:extLst>
           </p:cNvPr>
@@ -9298,8 +9261,8 @@
         </p:blipFill>
         <p:spPr>
           <a:xfrm>
-            <a:off x="1754270" y="3982580"/>
-            <a:ext cx="3116850" cy="1684166"/>
+            <a:off x="8937335" y="1348503"/>
+            <a:ext cx="2819644" cy="922100"/>
           </a:xfrm>
           <a:prstGeom prst="rect">
             <a:avLst/>
@@ -9308,10 +9271,10 @@
       </p:pic>
       <p:pic>
         <p:nvPicPr>
-          <p:cNvPr id="6" name="Picture 5">
-            <a:extLst>
-              <a:ext uri="{FF2B5EF4-FFF2-40B4-BE49-F238E27FC236}">
-                <a16:creationId xmlns:a16="http://schemas.microsoft.com/office/drawing/2014/main" id="{8069EE7F-3ADD-BCF5-DA33-8BC0EF2C17DE}"/>
+          <p:cNvPr id="7" name="Picture 6">
+            <a:extLst>
+              <a:ext uri="{FF2B5EF4-FFF2-40B4-BE49-F238E27FC236}">
+                <a16:creationId xmlns:a16="http://schemas.microsoft.com/office/drawing/2014/main" id="{AB881366-0923-6C77-442D-F11A8DF6AA1B}"/>
               </a:ext>
             </a:extLst>
           </p:cNvPr>
@@ -9328,8 +9291,8 @@
         </p:blipFill>
         <p:spPr>
           <a:xfrm>
-            <a:off x="6185041" y="3982580"/>
-            <a:ext cx="4458086" cy="1653683"/>
+            <a:off x="1054769" y="3034623"/>
+            <a:ext cx="9929720" cy="2644369"/>
           </a:xfrm>
           <a:prstGeom prst="rect">
             <a:avLst/>
@@ -9339,7 +9302,7 @@
     </p:spTree>
     <p:extLst>
       <p:ext uri="{BB962C8B-B14F-4D97-AF65-F5344CB8AC3E}">
-        <p14:creationId xmlns:p14="http://schemas.microsoft.com/office/powerpoint/2010/main" val="165987618"/>
+        <p14:creationId xmlns:p14="http://schemas.microsoft.com/office/powerpoint/2010/main" val="2520883108"/>
       </p:ext>
     </p:extLst>
   </p:cSld>
@@ -9433,11 +9396,45 @@
             </a:r>
             <a:r>
               <a:rPr lang="en-US" b="1" dirty="0"/>
-              <a:t>sum </a:t>
-            </a:r>
-            <a:r>
-              <a:rPr lang="en-US" dirty="0"/>
-              <a:t>to add up all of the values in a column</a:t>
+              <a:t>mean </a:t>
+            </a:r>
+            <a:r>
+              <a:rPr lang="en-US" dirty="0"/>
+              <a:t>to compute the average value of a column</a:t>
+            </a:r>
+          </a:p>
+          <a:p>
+            <a:endParaRPr lang="en-US" dirty="0"/>
+          </a:p>
+          <a:p>
+            <a:endParaRPr lang="en-US" dirty="0"/>
+          </a:p>
+          <a:p>
+            <a:endParaRPr lang="en-US" dirty="0"/>
+          </a:p>
+          <a:p>
+            <a:endParaRPr lang="en-US" dirty="0"/>
+          </a:p>
+          <a:p>
+            <a:r>
+              <a:rPr lang="en-US" dirty="0"/>
+              <a:t>We use </a:t>
+            </a:r>
+            <a:r>
+              <a:rPr lang="en-US" b="1" dirty="0"/>
+              <a:t>max</a:t>
+            </a:r>
+            <a:r>
+              <a:rPr lang="en-US" dirty="0"/>
+              <a:t> to get the maximum value of a column (and similar for </a:t>
+            </a:r>
+            <a:r>
+              <a:rPr lang="en-US" b="1" dirty="0"/>
+              <a:t>min</a:t>
+            </a:r>
+            <a:r>
+              <a:rPr lang="en-US" dirty="0"/>
+              <a:t>)</a:t>
             </a:r>
           </a:p>
           <a:p>
@@ -9453,10 +9450,10 @@
       </p:sp>
       <p:pic>
         <p:nvPicPr>
-          <p:cNvPr id="5" name="Picture 4">
-            <a:extLst>
-              <a:ext uri="{FF2B5EF4-FFF2-40B4-BE49-F238E27FC236}">
-                <a16:creationId xmlns:a16="http://schemas.microsoft.com/office/drawing/2014/main" id="{BD09B149-8511-7EA6-2166-588F352831FC}"/>
+          <p:cNvPr id="6" name="Picture 5">
+            <a:extLst>
+              <a:ext uri="{FF2B5EF4-FFF2-40B4-BE49-F238E27FC236}">
+                <a16:creationId xmlns:a16="http://schemas.microsoft.com/office/drawing/2014/main" id="{D7853F56-4B71-E29A-FFF9-916986FB7D1D}"/>
               </a:ext>
             </a:extLst>
           </p:cNvPr>
@@ -9473,8 +9470,8 @@
         </p:blipFill>
         <p:spPr>
           <a:xfrm>
-            <a:off x="8937335" y="1348503"/>
-            <a:ext cx="2819644" cy="922100"/>
+            <a:off x="4178643" y="2421303"/>
+            <a:ext cx="2888230" cy="922100"/>
           </a:xfrm>
           <a:prstGeom prst="rect">
             <a:avLst/>
@@ -9483,10 +9480,10 @@
       </p:pic>
       <p:pic>
         <p:nvPicPr>
-          <p:cNvPr id="7" name="Picture 6">
-            <a:extLst>
-              <a:ext uri="{FF2B5EF4-FFF2-40B4-BE49-F238E27FC236}">
-                <a16:creationId xmlns:a16="http://schemas.microsoft.com/office/drawing/2014/main" id="{AB881366-0923-6C77-442D-F11A8DF6AA1B}"/>
+          <p:cNvPr id="9" name="Picture 8">
+            <a:extLst>
+              <a:ext uri="{FF2B5EF4-FFF2-40B4-BE49-F238E27FC236}">
+                <a16:creationId xmlns:a16="http://schemas.microsoft.com/office/drawing/2014/main" id="{6F498782-53DE-1D9E-85F8-4D8C2B4E27B8}"/>
               </a:ext>
             </a:extLst>
           </p:cNvPr>
@@ -9503,215 +9500,6 @@
         </p:blipFill>
         <p:spPr>
           <a:xfrm>
-            <a:off x="1054769" y="3034623"/>
-            <a:ext cx="9929720" cy="2644369"/>
-          </a:xfrm>
-          <a:prstGeom prst="rect">
-            <a:avLst/>
-          </a:prstGeom>
-        </p:spPr>
-      </p:pic>
-    </p:spTree>
-    <p:extLst>
-      <p:ext uri="{BB962C8B-B14F-4D97-AF65-F5344CB8AC3E}">
-        <p14:creationId xmlns:p14="http://schemas.microsoft.com/office/powerpoint/2010/main" val="2520883108"/>
-      </p:ext>
-    </p:extLst>
-  </p:cSld>
-  <p:clrMapOvr>
-    <a:masterClrMapping/>
-  </p:clrMapOvr>
-  <mc:AlternateContent xmlns:mc="http://schemas.openxmlformats.org/markup-compatibility/2006" xmlns:p159="http://schemas.microsoft.com/office/powerpoint/2015/09/main">
-    <mc:Choice Requires="p159">
-      <p:transition xmlns:p14="http://schemas.microsoft.com/office/powerpoint/2010/main" spd="slow" p14:dur="2000">
-        <p159:morph option="byObject"/>
-      </p:transition>
-    </mc:Choice>
-    <mc:Fallback xmlns="">
-      <p:transition spd="slow">
-        <p:fade/>
-      </p:transition>
-    </mc:Fallback>
-  </mc:AlternateContent>
-</p:sld>
-</file>
-
-<file path=ppt/slides/slide34.xml><?xml version="1.0" encoding="utf-8"?>
-<p:sld xmlns:a="http://schemas.openxmlformats.org/drawingml/2006/main" xmlns:r="http://schemas.openxmlformats.org/officeDocument/2006/relationships" xmlns:p="http://schemas.openxmlformats.org/presentationml/2006/main">
-  <p:cSld>
-    <p:spTree>
-      <p:nvGrpSpPr>
-        <p:cNvPr id="1" name=""/>
-        <p:cNvGrpSpPr/>
-        <p:nvPr/>
-      </p:nvGrpSpPr>
-      <p:grpSpPr>
-        <a:xfrm>
-          <a:off x="0" y="0"/>
-          <a:ext cx="0" cy="0"/>
-          <a:chOff x="0" y="0"/>
-          <a:chExt cx="0" cy="0"/>
-        </a:xfrm>
-      </p:grpSpPr>
-      <p:sp>
-        <p:nvSpPr>
-          <p:cNvPr id="2" name="Title 1">
-            <a:extLst>
-              <a:ext uri="{FF2B5EF4-FFF2-40B4-BE49-F238E27FC236}">
-                <a16:creationId xmlns:a16="http://schemas.microsoft.com/office/drawing/2014/main" id="{E7ACD6AE-8BC7-CBA0-ECF3-6BDC6486E270}"/>
-              </a:ext>
-            </a:extLst>
-          </p:cNvPr>
-          <p:cNvSpPr>
-            <a:spLocks noGrp="1"/>
-          </p:cNvSpPr>
-          <p:nvPr>
-            <p:ph type="title"/>
-          </p:nvPr>
-        </p:nvSpPr>
-        <p:spPr/>
-        <p:txBody>
-          <a:bodyPr/>
-          <a:lstStyle/>
-          <a:p>
-            <a:r>
-              <a:rPr lang="en-US" dirty="0"/>
-              <a:t>Other common functions on columns</a:t>
-            </a:r>
-          </a:p>
-        </p:txBody>
-      </p:sp>
-      <p:sp>
-        <p:nvSpPr>
-          <p:cNvPr id="3" name="Content Placeholder 2">
-            <a:extLst>
-              <a:ext uri="{FF2B5EF4-FFF2-40B4-BE49-F238E27FC236}">
-                <a16:creationId xmlns:a16="http://schemas.microsoft.com/office/drawing/2014/main" id="{1D5F2DE6-6409-9194-5C91-FE26930FB48B}"/>
-              </a:ext>
-            </a:extLst>
-          </p:cNvPr>
-          <p:cNvSpPr>
-            <a:spLocks noGrp="1"/>
-          </p:cNvSpPr>
-          <p:nvPr>
-            <p:ph idx="1"/>
-          </p:nvPr>
-        </p:nvSpPr>
-        <p:spPr/>
-        <p:txBody>
-          <a:bodyPr/>
-          <a:lstStyle/>
-          <a:p>
-            <a:r>
-              <a:rPr lang="en-US" dirty="0"/>
-              <a:t>We use </a:t>
-            </a:r>
-            <a:r>
-              <a:rPr lang="en-US" b="1" dirty="0"/>
-              <a:t>mean </a:t>
-            </a:r>
-            <a:r>
-              <a:rPr lang="en-US" dirty="0"/>
-              <a:t>to compute the average value of a column</a:t>
-            </a:r>
-          </a:p>
-          <a:p>
-            <a:endParaRPr lang="en-US" dirty="0"/>
-          </a:p>
-          <a:p>
-            <a:endParaRPr lang="en-US" dirty="0"/>
-          </a:p>
-          <a:p>
-            <a:endParaRPr lang="en-US" dirty="0"/>
-          </a:p>
-          <a:p>
-            <a:endParaRPr lang="en-US" dirty="0"/>
-          </a:p>
-          <a:p>
-            <a:r>
-              <a:rPr lang="en-US" dirty="0"/>
-              <a:t>We use </a:t>
-            </a:r>
-            <a:r>
-              <a:rPr lang="en-US" b="1" dirty="0"/>
-              <a:t>max</a:t>
-            </a:r>
-            <a:r>
-              <a:rPr lang="en-US" dirty="0"/>
-              <a:t> to get the maximum value of a column (and similar for </a:t>
-            </a:r>
-            <a:r>
-              <a:rPr lang="en-US" b="1" dirty="0"/>
-              <a:t>min</a:t>
-            </a:r>
-            <a:r>
-              <a:rPr lang="en-US" dirty="0"/>
-              <a:t>)</a:t>
-            </a:r>
-          </a:p>
-          <a:p>
-            <a:endParaRPr lang="en-US" b="1" dirty="0"/>
-          </a:p>
-          <a:p>
-            <a:pPr marL="0" indent="0">
-              <a:buNone/>
-            </a:pPr>
-            <a:endParaRPr lang="en-US" dirty="0"/>
-          </a:p>
-        </p:txBody>
-      </p:sp>
-      <p:pic>
-        <p:nvPicPr>
-          <p:cNvPr id="6" name="Picture 5">
-            <a:extLst>
-              <a:ext uri="{FF2B5EF4-FFF2-40B4-BE49-F238E27FC236}">
-                <a16:creationId xmlns:a16="http://schemas.microsoft.com/office/drawing/2014/main" id="{D7853F56-4B71-E29A-FFF9-916986FB7D1D}"/>
-              </a:ext>
-            </a:extLst>
-          </p:cNvPr>
-          <p:cNvPicPr>
-            <a:picLocks noChangeAspect="1"/>
-          </p:cNvPicPr>
-          <p:nvPr/>
-        </p:nvPicPr>
-        <p:blipFill>
-          <a:blip r:embed="rId2"/>
-          <a:stretch>
-            <a:fillRect/>
-          </a:stretch>
-        </p:blipFill>
-        <p:spPr>
-          <a:xfrm>
-            <a:off x="4178643" y="2421303"/>
-            <a:ext cx="2888230" cy="922100"/>
-          </a:xfrm>
-          <a:prstGeom prst="rect">
-            <a:avLst/>
-          </a:prstGeom>
-        </p:spPr>
-      </p:pic>
-      <p:pic>
-        <p:nvPicPr>
-          <p:cNvPr id="9" name="Picture 8">
-            <a:extLst>
-              <a:ext uri="{FF2B5EF4-FFF2-40B4-BE49-F238E27FC236}">
-                <a16:creationId xmlns:a16="http://schemas.microsoft.com/office/drawing/2014/main" id="{6F498782-53DE-1D9E-85F8-4D8C2B4E27B8}"/>
-              </a:ext>
-            </a:extLst>
-          </p:cNvPr>
-          <p:cNvPicPr>
-            <a:picLocks noChangeAspect="1"/>
-          </p:cNvPicPr>
-          <p:nvPr/>
-        </p:nvPicPr>
-        <p:blipFill>
-          <a:blip r:embed="rId3"/>
-          <a:stretch>
-            <a:fillRect/>
-          </a:stretch>
-        </p:blipFill>
-        <p:spPr>
-          <a:xfrm>
             <a:off x="4178643" y="5213845"/>
             <a:ext cx="2850127" cy="922100"/>
           </a:xfrm>
@@ -9724,655 +9512,6 @@
     <p:extLst>
       <p:ext uri="{BB962C8B-B14F-4D97-AF65-F5344CB8AC3E}">
         <p14:creationId xmlns:p14="http://schemas.microsoft.com/office/powerpoint/2010/main" val="1590133847"/>
-      </p:ext>
-    </p:extLst>
-  </p:cSld>
-  <p:clrMapOvr>
-    <a:masterClrMapping/>
-  </p:clrMapOvr>
-  <mc:AlternateContent xmlns:mc="http://schemas.openxmlformats.org/markup-compatibility/2006" xmlns:p159="http://schemas.microsoft.com/office/powerpoint/2015/09/main">
-    <mc:Choice Requires="p159">
-      <p:transition xmlns:p14="http://schemas.microsoft.com/office/powerpoint/2010/main" spd="slow" p14:dur="2000">
-        <p159:morph option="byObject"/>
-      </p:transition>
-    </mc:Choice>
-    <mc:Fallback xmlns="">
-      <p:transition spd="slow">
-        <p:fade/>
-      </p:transition>
-    </mc:Fallback>
-  </mc:AlternateContent>
-</p:sld>
-</file>
-
-<file path=ppt/slides/slide35.xml><?xml version="1.0" encoding="utf-8"?>
-<p:sld xmlns:a="http://schemas.openxmlformats.org/drawingml/2006/main" xmlns:r="http://schemas.openxmlformats.org/officeDocument/2006/relationships" xmlns:p="http://schemas.openxmlformats.org/presentationml/2006/main">
-  <p:cSld>
-    <p:spTree>
-      <p:nvGrpSpPr>
-        <p:cNvPr id="1" name=""/>
-        <p:cNvGrpSpPr/>
-        <p:nvPr/>
-      </p:nvGrpSpPr>
-      <p:grpSpPr>
-        <a:xfrm>
-          <a:off x="0" y="0"/>
-          <a:ext cx="0" cy="0"/>
-          <a:chOff x="0" y="0"/>
-          <a:chExt cx="0" cy="0"/>
-        </a:xfrm>
-      </p:grpSpPr>
-      <p:sp>
-        <p:nvSpPr>
-          <p:cNvPr id="2" name="Title 1">
-            <a:extLst>
-              <a:ext uri="{FF2B5EF4-FFF2-40B4-BE49-F238E27FC236}">
-                <a16:creationId xmlns:a16="http://schemas.microsoft.com/office/drawing/2014/main" id="{F6574D11-F7AC-D9E3-0DE3-1F5970A2F1FE}"/>
-              </a:ext>
-            </a:extLst>
-          </p:cNvPr>
-          <p:cNvSpPr>
-            <a:spLocks noGrp="1"/>
-          </p:cNvSpPr>
-          <p:nvPr>
-            <p:ph type="title"/>
-          </p:nvPr>
-        </p:nvSpPr>
-        <p:spPr/>
-        <p:txBody>
-          <a:bodyPr/>
-          <a:lstStyle/>
-          <a:p>
-            <a:r>
-              <a:rPr lang="en-US" dirty="0"/>
-              <a:t>Using logic to access rows</a:t>
-            </a:r>
-          </a:p>
-        </p:txBody>
-      </p:sp>
-      <p:sp>
-        <p:nvSpPr>
-          <p:cNvPr id="3" name="Content Placeholder 2">
-            <a:extLst>
-              <a:ext uri="{FF2B5EF4-FFF2-40B4-BE49-F238E27FC236}">
-                <a16:creationId xmlns:a16="http://schemas.microsoft.com/office/drawing/2014/main" id="{F464724D-D53E-2FBB-2861-6332E42D8F0D}"/>
-              </a:ext>
-            </a:extLst>
-          </p:cNvPr>
-          <p:cNvSpPr>
-            <a:spLocks noGrp="1"/>
-          </p:cNvSpPr>
-          <p:nvPr>
-            <p:ph idx="1"/>
-          </p:nvPr>
-        </p:nvSpPr>
-        <p:spPr/>
-        <p:txBody>
-          <a:bodyPr/>
-          <a:lstStyle/>
-          <a:p>
-            <a:r>
-              <a:rPr lang="en-US" dirty="0"/>
-              <a:t>We are talking about accessing parts of a </a:t>
-            </a:r>
-            <a:r>
-              <a:rPr lang="en-US" dirty="0" err="1"/>
-              <a:t>DataFrame</a:t>
-            </a:r>
-            <a:r>
-              <a:rPr lang="en-US" dirty="0"/>
-              <a:t> so we are going to be using brackets here</a:t>
-            </a:r>
-          </a:p>
-          <a:p>
-            <a:r>
-              <a:rPr lang="en-US" dirty="0"/>
-              <a:t>We are going to use logical conditions, so that means we’ll use </a:t>
-            </a:r>
-          </a:p>
-          <a:p>
-            <a:pPr lvl="1"/>
-            <a:r>
-              <a:rPr lang="en-US" dirty="0"/>
-              <a:t>== (is equal to)</a:t>
-            </a:r>
-          </a:p>
-          <a:p>
-            <a:pPr lvl="1"/>
-            <a:r>
-              <a:rPr lang="en-US" dirty="0"/>
-              <a:t>!= (is NOT equal to)</a:t>
-            </a:r>
-          </a:p>
-          <a:p>
-            <a:pPr lvl="1"/>
-            <a:r>
-              <a:rPr lang="en-US" dirty="0"/>
-              <a:t>&gt; (is greater than)</a:t>
-            </a:r>
-          </a:p>
-          <a:p>
-            <a:pPr lvl="1"/>
-            <a:r>
-              <a:rPr lang="en-US" dirty="0"/>
-              <a:t>&lt; (is less than)</a:t>
-            </a:r>
-          </a:p>
-          <a:p>
-            <a:pPr lvl="1"/>
-            <a:r>
-              <a:rPr lang="en-US" dirty="0"/>
-              <a:t>&gt;= (is greater than or equal to)</a:t>
-            </a:r>
-          </a:p>
-          <a:p>
-            <a:pPr lvl="1"/>
-            <a:r>
-              <a:rPr lang="en-US" dirty="0"/>
-              <a:t>&lt;= (is less than or equal to_</a:t>
-            </a:r>
-          </a:p>
-        </p:txBody>
-      </p:sp>
-    </p:spTree>
-    <p:extLst>
-      <p:ext uri="{BB962C8B-B14F-4D97-AF65-F5344CB8AC3E}">
-        <p14:creationId xmlns:p14="http://schemas.microsoft.com/office/powerpoint/2010/main" val="394869943"/>
-      </p:ext>
-    </p:extLst>
-  </p:cSld>
-  <p:clrMapOvr>
-    <a:masterClrMapping/>
-  </p:clrMapOvr>
-  <mc:AlternateContent xmlns:mc="http://schemas.openxmlformats.org/markup-compatibility/2006" xmlns:p159="http://schemas.microsoft.com/office/powerpoint/2015/09/main">
-    <mc:Choice Requires="p159">
-      <p:transition xmlns:p14="http://schemas.microsoft.com/office/powerpoint/2010/main" spd="slow" p14:dur="2000">
-        <p159:morph option="byObject"/>
-      </p:transition>
-    </mc:Choice>
-    <mc:Fallback xmlns="">
-      <p:transition spd="slow">
-        <p:fade/>
-      </p:transition>
-    </mc:Fallback>
-  </mc:AlternateContent>
-</p:sld>
-</file>
-
-<file path=ppt/slides/slide36.xml><?xml version="1.0" encoding="utf-8"?>
-<p:sld xmlns:a="http://schemas.openxmlformats.org/drawingml/2006/main" xmlns:r="http://schemas.openxmlformats.org/officeDocument/2006/relationships" xmlns:p="http://schemas.openxmlformats.org/presentationml/2006/main">
-  <p:cSld>
-    <p:spTree>
-      <p:nvGrpSpPr>
-        <p:cNvPr id="1" name=""/>
-        <p:cNvGrpSpPr/>
-        <p:nvPr/>
-      </p:nvGrpSpPr>
-      <p:grpSpPr>
-        <a:xfrm>
-          <a:off x="0" y="0"/>
-          <a:ext cx="0" cy="0"/>
-          <a:chOff x="0" y="0"/>
-          <a:chExt cx="0" cy="0"/>
-        </a:xfrm>
-      </p:grpSpPr>
-      <p:sp>
-        <p:nvSpPr>
-          <p:cNvPr id="2" name="Title 1">
-            <a:extLst>
-              <a:ext uri="{FF2B5EF4-FFF2-40B4-BE49-F238E27FC236}">
-                <a16:creationId xmlns:a16="http://schemas.microsoft.com/office/drawing/2014/main" id="{B86C1926-5360-E508-02EB-F50E7647876E}"/>
-              </a:ext>
-            </a:extLst>
-          </p:cNvPr>
-          <p:cNvSpPr>
-            <a:spLocks noGrp="1"/>
-          </p:cNvSpPr>
-          <p:nvPr>
-            <p:ph type="title"/>
-          </p:nvPr>
-        </p:nvSpPr>
-        <p:spPr/>
-        <p:txBody>
-          <a:bodyPr/>
-          <a:lstStyle/>
-          <a:p>
-            <a:r>
-              <a:rPr lang="en-US" dirty="0"/>
-              <a:t>Limit to 2019 data</a:t>
-            </a:r>
-          </a:p>
-        </p:txBody>
-      </p:sp>
-      <p:sp>
-        <p:nvSpPr>
-          <p:cNvPr id="3" name="Content Placeholder 2">
-            <a:extLst>
-              <a:ext uri="{FF2B5EF4-FFF2-40B4-BE49-F238E27FC236}">
-                <a16:creationId xmlns:a16="http://schemas.microsoft.com/office/drawing/2014/main" id="{9D2778AB-5DCB-1B74-789F-EB19C81A9A2B}"/>
-              </a:ext>
-            </a:extLst>
-          </p:cNvPr>
-          <p:cNvSpPr>
-            <a:spLocks noGrp="1"/>
-          </p:cNvSpPr>
-          <p:nvPr>
-            <p:ph idx="1"/>
-          </p:nvPr>
-        </p:nvSpPr>
-        <p:spPr/>
-        <p:txBody>
-          <a:bodyPr/>
-          <a:lstStyle/>
-          <a:p>
-            <a:endParaRPr lang="en-US"/>
-          </a:p>
-        </p:txBody>
-      </p:sp>
-      <p:pic>
-        <p:nvPicPr>
-          <p:cNvPr id="7" name="Picture 6">
-            <a:extLst>
-              <a:ext uri="{FF2B5EF4-FFF2-40B4-BE49-F238E27FC236}">
-                <a16:creationId xmlns:a16="http://schemas.microsoft.com/office/drawing/2014/main" id="{7C272B68-B34F-C358-0C96-6E0FD83AD153}"/>
-              </a:ext>
-            </a:extLst>
-          </p:cNvPr>
-          <p:cNvPicPr>
-            <a:picLocks noChangeAspect="1"/>
-          </p:cNvPicPr>
-          <p:nvPr/>
-        </p:nvPicPr>
-        <p:blipFill>
-          <a:blip r:embed="rId2"/>
-          <a:stretch>
-            <a:fillRect/>
-          </a:stretch>
-        </p:blipFill>
-        <p:spPr>
-          <a:xfrm>
-            <a:off x="1115898" y="1942721"/>
-            <a:ext cx="9960203" cy="4031329"/>
-          </a:xfrm>
-          <a:prstGeom prst="rect">
-            <a:avLst/>
-          </a:prstGeom>
-        </p:spPr>
-      </p:pic>
-    </p:spTree>
-    <p:extLst>
-      <p:ext uri="{BB962C8B-B14F-4D97-AF65-F5344CB8AC3E}">
-        <p14:creationId xmlns:p14="http://schemas.microsoft.com/office/powerpoint/2010/main" val="4052698250"/>
-      </p:ext>
-    </p:extLst>
-  </p:cSld>
-  <p:clrMapOvr>
-    <a:masterClrMapping/>
-  </p:clrMapOvr>
-  <mc:AlternateContent xmlns:mc="http://schemas.openxmlformats.org/markup-compatibility/2006" xmlns:p159="http://schemas.microsoft.com/office/powerpoint/2015/09/main">
-    <mc:Choice Requires="p159">
-      <p:transition xmlns:p14="http://schemas.microsoft.com/office/powerpoint/2010/main" spd="slow" p14:dur="2000">
-        <p159:morph option="byObject"/>
-      </p:transition>
-    </mc:Choice>
-    <mc:Fallback xmlns="">
-      <p:transition spd="slow">
-        <p:fade/>
-      </p:transition>
-    </mc:Fallback>
-  </mc:AlternateContent>
-</p:sld>
-</file>
-
-<file path=ppt/slides/slide37.xml><?xml version="1.0" encoding="utf-8"?>
-<p:sld xmlns:a="http://schemas.openxmlformats.org/drawingml/2006/main" xmlns:r="http://schemas.openxmlformats.org/officeDocument/2006/relationships" xmlns:p="http://schemas.openxmlformats.org/presentationml/2006/main">
-  <p:cSld>
-    <p:spTree>
-      <p:nvGrpSpPr>
-        <p:cNvPr id="1" name=""/>
-        <p:cNvGrpSpPr/>
-        <p:nvPr/>
-      </p:nvGrpSpPr>
-      <p:grpSpPr>
-        <a:xfrm>
-          <a:off x="0" y="0"/>
-          <a:ext cx="0" cy="0"/>
-          <a:chOff x="0" y="0"/>
-          <a:chExt cx="0" cy="0"/>
-        </a:xfrm>
-      </p:grpSpPr>
-      <p:sp>
-        <p:nvSpPr>
-          <p:cNvPr id="2" name="Title 1">
-            <a:extLst>
-              <a:ext uri="{FF2B5EF4-FFF2-40B4-BE49-F238E27FC236}">
-                <a16:creationId xmlns:a16="http://schemas.microsoft.com/office/drawing/2014/main" id="{8D611933-DB23-53E3-075F-B518478DBB58}"/>
-              </a:ext>
-            </a:extLst>
-          </p:cNvPr>
-          <p:cNvSpPr>
-            <a:spLocks noGrp="1"/>
-          </p:cNvSpPr>
-          <p:nvPr>
-            <p:ph type="title"/>
-          </p:nvPr>
-        </p:nvSpPr>
-        <p:spPr/>
-        <p:txBody>
-          <a:bodyPr/>
-          <a:lstStyle/>
-          <a:p>
-            <a:r>
-              <a:rPr lang="en-US" dirty="0"/>
-              <a:t>Example</a:t>
-            </a:r>
-          </a:p>
-        </p:txBody>
-      </p:sp>
-      <p:sp>
-        <p:nvSpPr>
-          <p:cNvPr id="3" name="Content Placeholder 2">
-            <a:extLst>
-              <a:ext uri="{FF2B5EF4-FFF2-40B4-BE49-F238E27FC236}">
-                <a16:creationId xmlns:a16="http://schemas.microsoft.com/office/drawing/2014/main" id="{5394E4A5-B70E-C763-6EC0-0073EE5549C2}"/>
-              </a:ext>
-            </a:extLst>
-          </p:cNvPr>
-          <p:cNvSpPr>
-            <a:spLocks noGrp="1"/>
-          </p:cNvSpPr>
-          <p:nvPr>
-            <p:ph idx="1"/>
-          </p:nvPr>
-        </p:nvSpPr>
-        <p:spPr/>
-        <p:txBody>
-          <a:bodyPr/>
-          <a:lstStyle/>
-          <a:p>
-            <a:r>
-              <a:rPr lang="en-US" dirty="0"/>
-              <a:t>Let’s now combine access rows, accessing columns, and performing an operation on a column</a:t>
-            </a:r>
-          </a:p>
-          <a:p>
-            <a:endParaRPr lang="en-US" dirty="0"/>
-          </a:p>
-        </p:txBody>
-      </p:sp>
-    </p:spTree>
-    <p:extLst>
-      <p:ext uri="{BB962C8B-B14F-4D97-AF65-F5344CB8AC3E}">
-        <p14:creationId xmlns:p14="http://schemas.microsoft.com/office/powerpoint/2010/main" val="1716991029"/>
-      </p:ext>
-    </p:extLst>
-  </p:cSld>
-  <p:clrMapOvr>
-    <a:masterClrMapping/>
-  </p:clrMapOvr>
-  <mc:AlternateContent xmlns:mc="http://schemas.openxmlformats.org/markup-compatibility/2006" xmlns:p159="http://schemas.microsoft.com/office/powerpoint/2015/09/main">
-    <mc:Choice Requires="p159">
-      <p:transition xmlns:p14="http://schemas.microsoft.com/office/powerpoint/2010/main" spd="slow" p14:dur="2000">
-        <p159:morph option="byObject"/>
-      </p:transition>
-    </mc:Choice>
-    <mc:Fallback xmlns="">
-      <p:transition spd="slow">
-        <p:fade/>
-      </p:transition>
-    </mc:Fallback>
-  </mc:AlternateContent>
-</p:sld>
-</file>
-
-<file path=ppt/slides/slide38.xml><?xml version="1.0" encoding="utf-8"?>
-<p:sld xmlns:a="http://schemas.openxmlformats.org/drawingml/2006/main" xmlns:r="http://schemas.openxmlformats.org/officeDocument/2006/relationships" xmlns:p="http://schemas.openxmlformats.org/presentationml/2006/main">
-  <p:cSld>
-    <p:spTree>
-      <p:nvGrpSpPr>
-        <p:cNvPr id="1" name=""/>
-        <p:cNvGrpSpPr/>
-        <p:nvPr/>
-      </p:nvGrpSpPr>
-      <p:grpSpPr>
-        <a:xfrm>
-          <a:off x="0" y="0"/>
-          <a:ext cx="0" cy="0"/>
-          <a:chOff x="0" y="0"/>
-          <a:chExt cx="0" cy="0"/>
-        </a:xfrm>
-      </p:grpSpPr>
-      <p:sp>
-        <p:nvSpPr>
-          <p:cNvPr id="2" name="Title 1">
-            <a:extLst>
-              <a:ext uri="{FF2B5EF4-FFF2-40B4-BE49-F238E27FC236}">
-                <a16:creationId xmlns:a16="http://schemas.microsoft.com/office/drawing/2014/main" id="{8D611933-DB23-53E3-075F-B518478DBB58}"/>
-              </a:ext>
-            </a:extLst>
-          </p:cNvPr>
-          <p:cNvSpPr>
-            <a:spLocks noGrp="1"/>
-          </p:cNvSpPr>
-          <p:nvPr>
-            <p:ph type="title"/>
-          </p:nvPr>
-        </p:nvSpPr>
-        <p:spPr/>
-        <p:txBody>
-          <a:bodyPr/>
-          <a:lstStyle/>
-          <a:p>
-            <a:r>
-              <a:rPr lang="en-US" dirty="0"/>
-              <a:t>Example</a:t>
-            </a:r>
-          </a:p>
-        </p:txBody>
-      </p:sp>
-      <p:sp>
-        <p:nvSpPr>
-          <p:cNvPr id="3" name="Content Placeholder 2">
-            <a:extLst>
-              <a:ext uri="{FF2B5EF4-FFF2-40B4-BE49-F238E27FC236}">
-                <a16:creationId xmlns:a16="http://schemas.microsoft.com/office/drawing/2014/main" id="{5394E4A5-B70E-C763-6EC0-0073EE5549C2}"/>
-              </a:ext>
-            </a:extLst>
-          </p:cNvPr>
-          <p:cNvSpPr>
-            <a:spLocks noGrp="1"/>
-          </p:cNvSpPr>
-          <p:nvPr>
-            <p:ph idx="1"/>
-          </p:nvPr>
-        </p:nvSpPr>
-        <p:spPr/>
-        <p:txBody>
-          <a:bodyPr/>
-          <a:lstStyle/>
-          <a:p>
-            <a:r>
-              <a:rPr lang="en-US" dirty="0"/>
-              <a:t>Let’s now combine access rows and accessing columns</a:t>
-            </a:r>
-          </a:p>
-          <a:p>
-            <a:endParaRPr lang="en-US" dirty="0"/>
-          </a:p>
-        </p:txBody>
-      </p:sp>
-      <p:pic>
-        <p:nvPicPr>
-          <p:cNvPr id="5" name="Picture 4">
-            <a:extLst>
-              <a:ext uri="{FF2B5EF4-FFF2-40B4-BE49-F238E27FC236}">
-                <a16:creationId xmlns:a16="http://schemas.microsoft.com/office/drawing/2014/main" id="{B2566981-59CF-EA38-B225-6BF14B514EEA}"/>
-              </a:ext>
-            </a:extLst>
-          </p:cNvPr>
-          <p:cNvPicPr>
-            <a:picLocks noChangeAspect="1"/>
-          </p:cNvPicPr>
-          <p:nvPr/>
-        </p:nvPicPr>
-        <p:blipFill>
-          <a:blip r:embed="rId2"/>
-          <a:stretch>
-            <a:fillRect/>
-          </a:stretch>
-        </p:blipFill>
-        <p:spPr>
-          <a:xfrm>
-            <a:off x="3394476" y="2302716"/>
-            <a:ext cx="5403048" cy="3589331"/>
-          </a:xfrm>
-          <a:prstGeom prst="rect">
-            <a:avLst/>
-          </a:prstGeom>
-        </p:spPr>
-      </p:pic>
-    </p:spTree>
-    <p:extLst>
-      <p:ext uri="{BB962C8B-B14F-4D97-AF65-F5344CB8AC3E}">
-        <p14:creationId xmlns:p14="http://schemas.microsoft.com/office/powerpoint/2010/main" val="4011489"/>
-      </p:ext>
-    </p:extLst>
-  </p:cSld>
-  <p:clrMapOvr>
-    <a:masterClrMapping/>
-  </p:clrMapOvr>
-  <mc:AlternateContent xmlns:mc="http://schemas.openxmlformats.org/markup-compatibility/2006" xmlns:p159="http://schemas.microsoft.com/office/powerpoint/2015/09/main">
-    <mc:Choice Requires="p159">
-      <p:transition xmlns:p14="http://schemas.microsoft.com/office/powerpoint/2010/main" spd="slow" p14:dur="2000">
-        <p159:morph option="byObject"/>
-      </p:transition>
-    </mc:Choice>
-    <mc:Fallback xmlns="">
-      <p:transition spd="slow">
-        <p:fade/>
-      </p:transition>
-    </mc:Fallback>
-  </mc:AlternateContent>
-</p:sld>
-</file>
-
-<file path=ppt/slides/slide39.xml><?xml version="1.0" encoding="utf-8"?>
-<p:sld xmlns:a="http://schemas.openxmlformats.org/drawingml/2006/main" xmlns:r="http://schemas.openxmlformats.org/officeDocument/2006/relationships" xmlns:p="http://schemas.openxmlformats.org/presentationml/2006/main">
-  <p:cSld>
-    <p:spTree>
-      <p:nvGrpSpPr>
-        <p:cNvPr id="1" name=""/>
-        <p:cNvGrpSpPr/>
-        <p:nvPr/>
-      </p:nvGrpSpPr>
-      <p:grpSpPr>
-        <a:xfrm>
-          <a:off x="0" y="0"/>
-          <a:ext cx="0" cy="0"/>
-          <a:chOff x="0" y="0"/>
-          <a:chExt cx="0" cy="0"/>
-        </a:xfrm>
-      </p:grpSpPr>
-      <p:sp>
-        <p:nvSpPr>
-          <p:cNvPr id="2" name="Title 1">
-            <a:extLst>
-              <a:ext uri="{FF2B5EF4-FFF2-40B4-BE49-F238E27FC236}">
-                <a16:creationId xmlns:a16="http://schemas.microsoft.com/office/drawing/2014/main" id="{8D611933-DB23-53E3-075F-B518478DBB58}"/>
-              </a:ext>
-            </a:extLst>
-          </p:cNvPr>
-          <p:cNvSpPr>
-            <a:spLocks noGrp="1"/>
-          </p:cNvSpPr>
-          <p:nvPr>
-            <p:ph type="title"/>
-          </p:nvPr>
-        </p:nvSpPr>
-        <p:spPr/>
-        <p:txBody>
-          <a:bodyPr/>
-          <a:lstStyle/>
-          <a:p>
-            <a:r>
-              <a:rPr lang="en-US" dirty="0"/>
-              <a:t>Example</a:t>
-            </a:r>
-          </a:p>
-        </p:txBody>
-      </p:sp>
-      <p:sp>
-        <p:nvSpPr>
-          <p:cNvPr id="3" name="Content Placeholder 2">
-            <a:extLst>
-              <a:ext uri="{FF2B5EF4-FFF2-40B4-BE49-F238E27FC236}">
-                <a16:creationId xmlns:a16="http://schemas.microsoft.com/office/drawing/2014/main" id="{5394E4A5-B70E-C763-6EC0-0073EE5549C2}"/>
-              </a:ext>
-            </a:extLst>
-          </p:cNvPr>
-          <p:cNvSpPr>
-            <a:spLocks noGrp="1"/>
-          </p:cNvSpPr>
-          <p:nvPr>
-            <p:ph idx="1"/>
-          </p:nvPr>
-        </p:nvSpPr>
-        <p:spPr/>
-        <p:txBody>
-          <a:bodyPr/>
-          <a:lstStyle/>
-          <a:p>
-            <a:r>
-              <a:rPr lang="en-US" dirty="0"/>
-              <a:t>Let’s now combine access rows and accessing columns</a:t>
-            </a:r>
-          </a:p>
-          <a:p>
-            <a:pPr lvl="1"/>
-            <a:r>
-              <a:rPr lang="en-US" dirty="0"/>
-              <a:t>We limit to rows where sex==‘M’ and look at the violent charge column</a:t>
-            </a:r>
-          </a:p>
-          <a:p>
-            <a:endParaRPr lang="en-US" dirty="0"/>
-          </a:p>
-        </p:txBody>
-      </p:sp>
-      <p:pic>
-        <p:nvPicPr>
-          <p:cNvPr id="5" name="Picture 4">
-            <a:extLst>
-              <a:ext uri="{FF2B5EF4-FFF2-40B4-BE49-F238E27FC236}">
-                <a16:creationId xmlns:a16="http://schemas.microsoft.com/office/drawing/2014/main" id="{B2566981-59CF-EA38-B225-6BF14B514EEA}"/>
-              </a:ext>
-            </a:extLst>
-          </p:cNvPr>
-          <p:cNvPicPr>
-            <a:picLocks noChangeAspect="1"/>
-          </p:cNvPicPr>
-          <p:nvPr/>
-        </p:nvPicPr>
-        <p:blipFill>
-          <a:blip r:embed="rId2"/>
-          <a:stretch>
-            <a:fillRect/>
-          </a:stretch>
-        </p:blipFill>
-        <p:spPr>
-          <a:xfrm>
-            <a:off x="3394476" y="2727832"/>
-            <a:ext cx="5403048" cy="3589331"/>
-          </a:xfrm>
-          <a:prstGeom prst="rect">
-            <a:avLst/>
-          </a:prstGeom>
-        </p:spPr>
-      </p:pic>
-    </p:spTree>
-    <p:extLst>
-      <p:ext uri="{BB962C8B-B14F-4D97-AF65-F5344CB8AC3E}">
-        <p14:creationId xmlns:p14="http://schemas.microsoft.com/office/powerpoint/2010/main" val="3438188534"/>
       </p:ext>
     </p:extLst>
   </p:cSld>
@@ -10933,141 +10072,6 @@
 </p:sld>
 </file>
 
-<file path=ppt/slides/slide40.xml><?xml version="1.0" encoding="utf-8"?>
-<p:sld xmlns:a="http://schemas.openxmlformats.org/drawingml/2006/main" xmlns:r="http://schemas.openxmlformats.org/officeDocument/2006/relationships" xmlns:p="http://schemas.openxmlformats.org/presentationml/2006/main">
-  <p:cSld>
-    <p:spTree>
-      <p:nvGrpSpPr>
-        <p:cNvPr id="1" name=""/>
-        <p:cNvGrpSpPr/>
-        <p:nvPr/>
-      </p:nvGrpSpPr>
-      <p:grpSpPr>
-        <a:xfrm>
-          <a:off x="0" y="0"/>
-          <a:ext cx="0" cy="0"/>
-          <a:chOff x="0" y="0"/>
-          <a:chExt cx="0" cy="0"/>
-        </a:xfrm>
-      </p:grpSpPr>
-      <p:sp>
-        <p:nvSpPr>
-          <p:cNvPr id="2" name="Title 1">
-            <a:extLst>
-              <a:ext uri="{FF2B5EF4-FFF2-40B4-BE49-F238E27FC236}">
-                <a16:creationId xmlns:a16="http://schemas.microsoft.com/office/drawing/2014/main" id="{8D611933-DB23-53E3-075F-B518478DBB58}"/>
-              </a:ext>
-            </a:extLst>
-          </p:cNvPr>
-          <p:cNvSpPr>
-            <a:spLocks noGrp="1"/>
-          </p:cNvSpPr>
-          <p:nvPr>
-            <p:ph type="title"/>
-          </p:nvPr>
-        </p:nvSpPr>
-        <p:spPr/>
-        <p:txBody>
-          <a:bodyPr/>
-          <a:lstStyle/>
-          <a:p>
-            <a:r>
-              <a:rPr lang="en-US" dirty="0"/>
-              <a:t>Example</a:t>
-            </a:r>
-          </a:p>
-        </p:txBody>
-      </p:sp>
-      <p:sp>
-        <p:nvSpPr>
-          <p:cNvPr id="3" name="Content Placeholder 2">
-            <a:extLst>
-              <a:ext uri="{FF2B5EF4-FFF2-40B4-BE49-F238E27FC236}">
-                <a16:creationId xmlns:a16="http://schemas.microsoft.com/office/drawing/2014/main" id="{5394E4A5-B70E-C763-6EC0-0073EE5549C2}"/>
-              </a:ext>
-            </a:extLst>
-          </p:cNvPr>
-          <p:cNvSpPr>
-            <a:spLocks noGrp="1"/>
-          </p:cNvSpPr>
-          <p:nvPr>
-            <p:ph idx="1"/>
-          </p:nvPr>
-        </p:nvSpPr>
-        <p:spPr/>
-        <p:txBody>
-          <a:bodyPr/>
-          <a:lstStyle/>
-          <a:p>
-            <a:r>
-              <a:rPr lang="en-US" dirty="0"/>
-              <a:t>Let’s now combine access rows, accessing columns, </a:t>
-            </a:r>
-            <a:r>
-              <a:rPr lang="en-US" b="1" dirty="0"/>
-              <a:t>and performing an operation on a column</a:t>
-            </a:r>
-          </a:p>
-          <a:p>
-            <a:endParaRPr lang="en-US" dirty="0"/>
-          </a:p>
-        </p:txBody>
-      </p:sp>
-      <p:pic>
-        <p:nvPicPr>
-          <p:cNvPr id="5" name="Picture 4">
-            <a:extLst>
-              <a:ext uri="{FF2B5EF4-FFF2-40B4-BE49-F238E27FC236}">
-                <a16:creationId xmlns:a16="http://schemas.microsoft.com/office/drawing/2014/main" id="{D829FD5A-3972-5CD3-2D1A-4D70E56DCD7F}"/>
-              </a:ext>
-            </a:extLst>
-          </p:cNvPr>
-          <p:cNvPicPr>
-            <a:picLocks noChangeAspect="1"/>
-          </p:cNvPicPr>
-          <p:nvPr/>
-        </p:nvPicPr>
-        <p:blipFill>
-          <a:blip r:embed="rId2"/>
-          <a:stretch>
-            <a:fillRect/>
-          </a:stretch>
-        </p:blipFill>
-        <p:spPr>
-          <a:xfrm>
-            <a:off x="3682265" y="2960329"/>
-            <a:ext cx="4602879" cy="937341"/>
-          </a:xfrm>
-          <a:prstGeom prst="rect">
-            <a:avLst/>
-          </a:prstGeom>
-        </p:spPr>
-      </p:pic>
-    </p:spTree>
-    <p:extLst>
-      <p:ext uri="{BB962C8B-B14F-4D97-AF65-F5344CB8AC3E}">
-        <p14:creationId xmlns:p14="http://schemas.microsoft.com/office/powerpoint/2010/main" val="4088717557"/>
-      </p:ext>
-    </p:extLst>
-  </p:cSld>
-  <p:clrMapOvr>
-    <a:masterClrMapping/>
-  </p:clrMapOvr>
-  <mc:AlternateContent xmlns:mc="http://schemas.openxmlformats.org/markup-compatibility/2006" xmlns:p159="http://schemas.microsoft.com/office/powerpoint/2015/09/main">
-    <mc:Choice Requires="p159">
-      <p:transition xmlns:p14="http://schemas.microsoft.com/office/powerpoint/2010/main" spd="slow" p14:dur="2000">
-        <p159:morph option="byObject"/>
-      </p:transition>
-    </mc:Choice>
-    <mc:Fallback xmlns="">
-      <p:transition spd="slow">
-        <p:fade/>
-      </p:transition>
-    </mc:Fallback>
-  </mc:AlternateContent>
-</p:sld>
-</file>
-
 <file path=ppt/slides/slide5.xml><?xml version="1.0" encoding="utf-8"?>
 <p:sld xmlns:a="http://schemas.openxmlformats.org/drawingml/2006/main" xmlns:r="http://schemas.openxmlformats.org/officeDocument/2006/relationships" xmlns:p="http://schemas.openxmlformats.org/presentationml/2006/main">
   <p:cSld>

</xml_diff>